<commit_message>
Include explicit live Vercel links, user survey Google Sheets link, and dense metric data across all 10 slides in NL_GooglePhotos.pptx
</commit_message>
<xml_diff>
--- a/output/NL_GooglePhotos.pptx
+++ b/output/NL_GooglePhotos.pptx
@@ -1852,7 +1852,7 @@
                             <a:srgbClr val="1A73E8"/>
                           </a:solidFill>
                         </a:rPr>
-                        <a:t>System Component</a:t>
+                        <a:t>System Component / Artifact</a:t>
                       </a:r>
                       <a:endParaRPr lang="en-US" sz="1400" dirty="0"/>
                     </a:p>
@@ -1913,7 +1913,7 @@
                             <a:srgbClr val="1A73E8"/>
                           </a:solidFill>
                         </a:rPr>
-                        <a:t>Role &amp; PM Capability</a:t>
+                        <a:t>Role &amp; Technical Capability</a:t>
                       </a:r>
                       <a:endParaRPr lang="en-US" sz="1400" dirty="0"/>
                     </a:p>
@@ -1974,7 +1974,7 @@
                             <a:srgbClr val="1A73E8"/>
                           </a:solidFill>
                         </a:rPr>
-                        <a:t>Deployed URL / Resource Link</a:t>
+                        <a:t>Public Deployed Link / Hyperlink</a:t>
                       </a:r>
                       <a:endParaRPr lang="en-US" sz="1400" dirty="0"/>
                     </a:p>
@@ -2590,190 +2590,190 @@
                             <a:srgbClr val="202124"/>
                           </a:solidFill>
                         </a:rPr>
-                        <a:t>Primary Research Form</a:t>
-                      </a:r>
-                      <a:endParaRPr lang="en-US" sz="1400" dirty="0"/>
-                    </a:p>
-                  </a:txBody>
-                  <a:tcPr marL="91440" marR="91440" marT="45720" marB="45720" anchor="ctr">
-                    <a:lnL w="12700" cap="flat" cmpd="sng" algn="ctr">
-                      <a:solidFill>
-                        <a:srgbClr val="DADCE0"/>
-                      </a:solidFill>
-                      <a:prstDash val="solid"/>
-                      <a:round/>
-                      <a:headEnd type="none" w="med" len="med"/>
-                      <a:tailEnd type="none" w="med" len="med"/>
-                    </a:lnL>
-                    <a:lnR w="12700" cap="flat" cmpd="sng" algn="ctr">
-                      <a:solidFill>
-                        <a:srgbClr val="DADCE0"/>
-                      </a:solidFill>
-                      <a:prstDash val="solid"/>
-                      <a:round/>
-                      <a:headEnd type="none" w="med" len="med"/>
-                      <a:tailEnd type="none" w="med" len="med"/>
-                    </a:lnR>
-                    <a:lnT w="12700" cap="flat" cmpd="sng" algn="ctr">
-                      <a:solidFill>
-                        <a:srgbClr val="DADCE0"/>
-                      </a:solidFill>
-                      <a:prstDash val="solid"/>
-                      <a:round/>
-                      <a:headEnd type="none" w="med" len="med"/>
-                      <a:tailEnd type="none" w="med" len="med"/>
-                    </a:lnT>
-                    <a:lnB w="12700" cap="flat" cmpd="sng" algn="ctr">
-                      <a:solidFill>
-                        <a:srgbClr val="DADCE0"/>
-                      </a:solidFill>
-                      <a:prstDash val="solid"/>
-                      <a:round/>
-                      <a:headEnd type="none" w="med" len="med"/>
-                      <a:tailEnd type="none" w="med" len="med"/>
-                    </a:lnB>
-                    <a:solidFill>
-                      <a:srgbClr val="FFFFFF"/>
-                    </a:solidFill>
-                  </a:tcPr>
-                </a:tc>
-                <a:tc>
-                  <a:txBody>
-                    <a:bodyPr/>
-                    <a:lstStyle/>
-                    <a:p>
-                      <a:pPr algn="l" indent="0" marL="0">
-                        <a:buNone/>
-                      </a:pPr>
-                      <a:r>
-                        <a:rPr lang="en-US" sz="1400" dirty="0">
-                          <a:solidFill>
-                            <a:srgbClr val="202124"/>
-                          </a:solidFill>
-                        </a:rPr>
-                        <a:t>15-Question User Research Automation Tool</a:t>
-                      </a:r>
-                      <a:endParaRPr lang="en-US" sz="1400" dirty="0"/>
-                    </a:p>
-                  </a:txBody>
-                  <a:tcPr marL="91440" marR="91440" marT="45720" marB="45720" anchor="ctr">
-                    <a:lnL w="12700" cap="flat" cmpd="sng" algn="ctr">
-                      <a:solidFill>
-                        <a:srgbClr val="DADCE0"/>
-                      </a:solidFill>
-                      <a:prstDash val="solid"/>
-                      <a:round/>
-                      <a:headEnd type="none" w="med" len="med"/>
-                      <a:tailEnd type="none" w="med" len="med"/>
-                    </a:lnL>
-                    <a:lnR w="12700" cap="flat" cmpd="sng" algn="ctr">
-                      <a:solidFill>
-                        <a:srgbClr val="DADCE0"/>
-                      </a:solidFill>
-                      <a:prstDash val="solid"/>
-                      <a:round/>
-                      <a:headEnd type="none" w="med" len="med"/>
-                      <a:tailEnd type="none" w="med" len="med"/>
-                    </a:lnR>
-                    <a:lnT w="12700" cap="flat" cmpd="sng" algn="ctr">
-                      <a:solidFill>
-                        <a:srgbClr val="DADCE0"/>
-                      </a:solidFill>
-                      <a:prstDash val="solid"/>
-                      <a:round/>
-                      <a:headEnd type="none" w="med" len="med"/>
-                      <a:tailEnd type="none" w="med" len="med"/>
-                    </a:lnT>
-                    <a:lnB w="12700" cap="flat" cmpd="sng" algn="ctr">
-                      <a:solidFill>
-                        <a:srgbClr val="DADCE0"/>
-                      </a:solidFill>
-                      <a:prstDash val="solid"/>
-                      <a:round/>
-                      <a:headEnd type="none" w="med" len="med"/>
-                      <a:tailEnd type="none" w="med" len="med"/>
-                    </a:lnB>
-                    <a:solidFill>
-                      <a:srgbClr val="FFFFFF"/>
-                    </a:solidFill>
-                  </a:tcPr>
-                </a:tc>
-                <a:tc>
-                  <a:txBody>
-                    <a:bodyPr/>
-                    <a:lstStyle/>
-                    <a:p>
-                      <a:pPr algn="l" indent="0" marL="0">
-                        <a:buNone/>
-                      </a:pPr>
-                      <a:r>
-                        <a:rPr lang="en-US" sz="1400" dirty="0">
-                          <a:solidFill>
-                            <a:srgbClr val="202124"/>
-                          </a:solidFill>
-                        </a:rPr>
-                        <a:t>https://google-photos-vague-memory-discover.vercel.app/google_form.html</a:t>
-                      </a:r>
-                      <a:endParaRPr lang="en-US" sz="1400" dirty="0"/>
-                    </a:p>
-                  </a:txBody>
-                  <a:tcPr marL="91440" marR="91440" marT="45720" marB="45720" anchor="ctr">
-                    <a:lnL w="12700" cap="flat" cmpd="sng" algn="ctr">
-                      <a:solidFill>
-                        <a:srgbClr val="DADCE0"/>
-                      </a:solidFill>
-                      <a:prstDash val="solid"/>
-                      <a:round/>
-                      <a:headEnd type="none" w="med" len="med"/>
-                      <a:tailEnd type="none" w="med" len="med"/>
-                    </a:lnL>
-                    <a:lnR w="12700" cap="flat" cmpd="sng" algn="ctr">
-                      <a:solidFill>
-                        <a:srgbClr val="DADCE0"/>
-                      </a:solidFill>
-                      <a:prstDash val="solid"/>
-                      <a:round/>
-                      <a:headEnd type="none" w="med" len="med"/>
-                      <a:tailEnd type="none" w="med" len="med"/>
-                    </a:lnR>
-                    <a:lnT w="12700" cap="flat" cmpd="sng" algn="ctr">
-                      <a:solidFill>
-                        <a:srgbClr val="DADCE0"/>
-                      </a:solidFill>
-                      <a:prstDash val="solid"/>
-                      <a:round/>
-                      <a:headEnd type="none" w="med" len="med"/>
-                      <a:tailEnd type="none" w="med" len="med"/>
-                    </a:lnT>
-                    <a:lnB w="12700" cap="flat" cmpd="sng" algn="ctr">
-                      <a:solidFill>
-                        <a:srgbClr val="DADCE0"/>
-                      </a:solidFill>
-                      <a:prstDash val="solid"/>
-                      <a:round/>
-                      <a:headEnd type="none" w="med" len="med"/>
-                      <a:tailEnd type="none" w="med" len="med"/>
-                    </a:lnB>
-                    <a:solidFill>
-                      <a:srgbClr val="FFFFFF"/>
-                    </a:solidFill>
-                  </a:tcPr>
-                </a:tc>
-                <a:tc>
-                  <a:txBody>
-                    <a:bodyPr/>
-                    <a:lstStyle/>
-                    <a:p>
-                      <a:pPr algn="l" indent="0" marL="0">
-                        <a:buNone/>
-                      </a:pPr>
-                      <a:r>
-                        <a:rPr lang="en-US" sz="1400" dirty="0">
-                          <a:solidFill>
-                            <a:srgbClr val="202124"/>
-                          </a:solidFill>
-                        </a:rPr>
-                        <a:t>LIVE</a:t>
+                        <a:t>User Survey Datasheet</a:t>
+                      </a:r>
+                      <a:endParaRPr lang="en-US" sz="1400" dirty="0"/>
+                    </a:p>
+                  </a:txBody>
+                  <a:tcPr marL="91440" marR="91440" marT="45720" marB="45720" anchor="ctr">
+                    <a:lnL w="12700" cap="flat" cmpd="sng" algn="ctr">
+                      <a:solidFill>
+                        <a:srgbClr val="DADCE0"/>
+                      </a:solidFill>
+                      <a:prstDash val="solid"/>
+                      <a:round/>
+                      <a:headEnd type="none" w="med" len="med"/>
+                      <a:tailEnd type="none" w="med" len="med"/>
+                    </a:lnL>
+                    <a:lnR w="12700" cap="flat" cmpd="sng" algn="ctr">
+                      <a:solidFill>
+                        <a:srgbClr val="DADCE0"/>
+                      </a:solidFill>
+                      <a:prstDash val="solid"/>
+                      <a:round/>
+                      <a:headEnd type="none" w="med" len="med"/>
+                      <a:tailEnd type="none" w="med" len="med"/>
+                    </a:lnR>
+                    <a:lnT w="12700" cap="flat" cmpd="sng" algn="ctr">
+                      <a:solidFill>
+                        <a:srgbClr val="DADCE0"/>
+                      </a:solidFill>
+                      <a:prstDash val="solid"/>
+                      <a:round/>
+                      <a:headEnd type="none" w="med" len="med"/>
+                      <a:tailEnd type="none" w="med" len="med"/>
+                    </a:lnT>
+                    <a:lnB w="12700" cap="flat" cmpd="sng" algn="ctr">
+                      <a:solidFill>
+                        <a:srgbClr val="DADCE0"/>
+                      </a:solidFill>
+                      <a:prstDash val="solid"/>
+                      <a:round/>
+                      <a:headEnd type="none" w="med" len="med"/>
+                      <a:tailEnd type="none" w="med" len="med"/>
+                    </a:lnB>
+                    <a:solidFill>
+                      <a:srgbClr val="FFFFFF"/>
+                    </a:solidFill>
+                  </a:tcPr>
+                </a:tc>
+                <a:tc>
+                  <a:txBody>
+                    <a:bodyPr/>
+                    <a:lstStyle/>
+                    <a:p>
+                      <a:pPr algn="l" indent="0" marL="0">
+                        <a:buNone/>
+                      </a:pPr>
+                      <a:r>
+                        <a:rPr lang="en-US" sz="1400" dirty="0">
+                          <a:solidFill>
+                            <a:srgbClr val="202124"/>
+                          </a:solidFill>
+                        </a:rPr>
+                        <a:t>N=34 Primary Research Raw Response Sheet</a:t>
+                      </a:r>
+                      <a:endParaRPr lang="en-US" sz="1400" dirty="0"/>
+                    </a:p>
+                  </a:txBody>
+                  <a:tcPr marL="91440" marR="91440" marT="45720" marB="45720" anchor="ctr">
+                    <a:lnL w="12700" cap="flat" cmpd="sng" algn="ctr">
+                      <a:solidFill>
+                        <a:srgbClr val="DADCE0"/>
+                      </a:solidFill>
+                      <a:prstDash val="solid"/>
+                      <a:round/>
+                      <a:headEnd type="none" w="med" len="med"/>
+                      <a:tailEnd type="none" w="med" len="med"/>
+                    </a:lnL>
+                    <a:lnR w="12700" cap="flat" cmpd="sng" algn="ctr">
+                      <a:solidFill>
+                        <a:srgbClr val="DADCE0"/>
+                      </a:solidFill>
+                      <a:prstDash val="solid"/>
+                      <a:round/>
+                      <a:headEnd type="none" w="med" len="med"/>
+                      <a:tailEnd type="none" w="med" len="med"/>
+                    </a:lnR>
+                    <a:lnT w="12700" cap="flat" cmpd="sng" algn="ctr">
+                      <a:solidFill>
+                        <a:srgbClr val="DADCE0"/>
+                      </a:solidFill>
+                      <a:prstDash val="solid"/>
+                      <a:round/>
+                      <a:headEnd type="none" w="med" len="med"/>
+                      <a:tailEnd type="none" w="med" len="med"/>
+                    </a:lnT>
+                    <a:lnB w="12700" cap="flat" cmpd="sng" algn="ctr">
+                      <a:solidFill>
+                        <a:srgbClr val="DADCE0"/>
+                      </a:solidFill>
+                      <a:prstDash val="solid"/>
+                      <a:round/>
+                      <a:headEnd type="none" w="med" len="med"/>
+                      <a:tailEnd type="none" w="med" len="med"/>
+                    </a:lnB>
+                    <a:solidFill>
+                      <a:srgbClr val="FFFFFF"/>
+                    </a:solidFill>
+                  </a:tcPr>
+                </a:tc>
+                <a:tc>
+                  <a:txBody>
+                    <a:bodyPr/>
+                    <a:lstStyle/>
+                    <a:p>
+                      <a:pPr algn="l" indent="0" marL="0">
+                        <a:buNone/>
+                      </a:pPr>
+                      <a:r>
+                        <a:rPr lang="en-US" sz="1400" dirty="0">
+                          <a:solidFill>
+                            <a:srgbClr val="202124"/>
+                          </a:solidFill>
+                        </a:rPr>
+                        <a:t>https://docs.google.com/spreadsheets/d/1IScTa4UfdjTZdB5UlyMu0AAd1g2LPlvGXwCgz1EAcow/edit?usp=sharing</a:t>
+                      </a:r>
+                      <a:endParaRPr lang="en-US" sz="1400" dirty="0"/>
+                    </a:p>
+                  </a:txBody>
+                  <a:tcPr marL="91440" marR="91440" marT="45720" marB="45720" anchor="ctr">
+                    <a:lnL w="12700" cap="flat" cmpd="sng" algn="ctr">
+                      <a:solidFill>
+                        <a:srgbClr val="DADCE0"/>
+                      </a:solidFill>
+                      <a:prstDash val="solid"/>
+                      <a:round/>
+                      <a:headEnd type="none" w="med" len="med"/>
+                      <a:tailEnd type="none" w="med" len="med"/>
+                    </a:lnL>
+                    <a:lnR w="12700" cap="flat" cmpd="sng" algn="ctr">
+                      <a:solidFill>
+                        <a:srgbClr val="DADCE0"/>
+                      </a:solidFill>
+                      <a:prstDash val="solid"/>
+                      <a:round/>
+                      <a:headEnd type="none" w="med" len="med"/>
+                      <a:tailEnd type="none" w="med" len="med"/>
+                    </a:lnR>
+                    <a:lnT w="12700" cap="flat" cmpd="sng" algn="ctr">
+                      <a:solidFill>
+                        <a:srgbClr val="DADCE0"/>
+                      </a:solidFill>
+                      <a:prstDash val="solid"/>
+                      <a:round/>
+                      <a:headEnd type="none" w="med" len="med"/>
+                      <a:tailEnd type="none" w="med" len="med"/>
+                    </a:lnT>
+                    <a:lnB w="12700" cap="flat" cmpd="sng" algn="ctr">
+                      <a:solidFill>
+                        <a:srgbClr val="DADCE0"/>
+                      </a:solidFill>
+                      <a:prstDash val="solid"/>
+                      <a:round/>
+                      <a:headEnd type="none" w="med" len="med"/>
+                      <a:tailEnd type="none" w="med" len="med"/>
+                    </a:lnB>
+                    <a:solidFill>
+                      <a:srgbClr val="FFFFFF"/>
+                    </a:solidFill>
+                  </a:tcPr>
+                </a:tc>
+                <a:tc>
+                  <a:txBody>
+                    <a:bodyPr/>
+                    <a:lstStyle/>
+                    <a:p>
+                      <a:pPr algn="l" indent="0" marL="0">
+                        <a:buNone/>
+                      </a:pPr>
+                      <a:r>
+                        <a:rPr lang="en-US" sz="1400" dirty="0">
+                          <a:solidFill>
+                            <a:srgbClr val="202124"/>
+                          </a:solidFill>
+                        </a:rPr>
+                        <a:t>LIVE SHEET</a:t>
                       </a:r>
                       <a:endParaRPr lang="en-US" sz="1400" dirty="0"/>
                     </a:p>
@@ -2836,6 +2836,252 @@
                             <a:srgbClr val="202124"/>
                           </a:solidFill>
                         </a:rPr>
+                        <a:t>Primary Research Form</a:t>
+                      </a:r>
+                      <a:endParaRPr lang="en-US" sz="1400" dirty="0"/>
+                    </a:p>
+                  </a:txBody>
+                  <a:tcPr marL="91440" marR="91440" marT="45720" marB="45720" anchor="ctr">
+                    <a:lnL w="12700" cap="flat" cmpd="sng" algn="ctr">
+                      <a:solidFill>
+                        <a:srgbClr val="DADCE0"/>
+                      </a:solidFill>
+                      <a:prstDash val="solid"/>
+                      <a:round/>
+                      <a:headEnd type="none" w="med" len="med"/>
+                      <a:tailEnd type="none" w="med" len="med"/>
+                    </a:lnL>
+                    <a:lnR w="12700" cap="flat" cmpd="sng" algn="ctr">
+                      <a:solidFill>
+                        <a:srgbClr val="DADCE0"/>
+                      </a:solidFill>
+                      <a:prstDash val="solid"/>
+                      <a:round/>
+                      <a:headEnd type="none" w="med" len="med"/>
+                      <a:tailEnd type="none" w="med" len="med"/>
+                    </a:lnR>
+                    <a:lnT w="12700" cap="flat" cmpd="sng" algn="ctr">
+                      <a:solidFill>
+                        <a:srgbClr val="DADCE0"/>
+                      </a:solidFill>
+                      <a:prstDash val="solid"/>
+                      <a:round/>
+                      <a:headEnd type="none" w="med" len="med"/>
+                      <a:tailEnd type="none" w="med" len="med"/>
+                    </a:lnT>
+                    <a:lnB w="12700" cap="flat" cmpd="sng" algn="ctr">
+                      <a:solidFill>
+                        <a:srgbClr val="DADCE0"/>
+                      </a:solidFill>
+                      <a:prstDash val="solid"/>
+                      <a:round/>
+                      <a:headEnd type="none" w="med" len="med"/>
+                      <a:tailEnd type="none" w="med" len="med"/>
+                    </a:lnB>
+                    <a:solidFill>
+                      <a:srgbClr val="FFFFFF"/>
+                    </a:solidFill>
+                  </a:tcPr>
+                </a:tc>
+                <a:tc>
+                  <a:txBody>
+                    <a:bodyPr/>
+                    <a:lstStyle/>
+                    <a:p>
+                      <a:pPr algn="l" indent="0" marL="0">
+                        <a:buNone/>
+                      </a:pPr>
+                      <a:r>
+                        <a:rPr lang="en-US" sz="1400" dirty="0">
+                          <a:solidFill>
+                            <a:srgbClr val="202124"/>
+                          </a:solidFill>
+                        </a:rPr>
+                        <a:t>15-Question User Research Automation Tool</a:t>
+                      </a:r>
+                      <a:endParaRPr lang="en-US" sz="1400" dirty="0"/>
+                    </a:p>
+                  </a:txBody>
+                  <a:tcPr marL="91440" marR="91440" marT="45720" marB="45720" anchor="ctr">
+                    <a:lnL w="12700" cap="flat" cmpd="sng" algn="ctr">
+                      <a:solidFill>
+                        <a:srgbClr val="DADCE0"/>
+                      </a:solidFill>
+                      <a:prstDash val="solid"/>
+                      <a:round/>
+                      <a:headEnd type="none" w="med" len="med"/>
+                      <a:tailEnd type="none" w="med" len="med"/>
+                    </a:lnL>
+                    <a:lnR w="12700" cap="flat" cmpd="sng" algn="ctr">
+                      <a:solidFill>
+                        <a:srgbClr val="DADCE0"/>
+                      </a:solidFill>
+                      <a:prstDash val="solid"/>
+                      <a:round/>
+                      <a:headEnd type="none" w="med" len="med"/>
+                      <a:tailEnd type="none" w="med" len="med"/>
+                    </a:lnR>
+                    <a:lnT w="12700" cap="flat" cmpd="sng" algn="ctr">
+                      <a:solidFill>
+                        <a:srgbClr val="DADCE0"/>
+                      </a:solidFill>
+                      <a:prstDash val="solid"/>
+                      <a:round/>
+                      <a:headEnd type="none" w="med" len="med"/>
+                      <a:tailEnd type="none" w="med" len="med"/>
+                    </a:lnT>
+                    <a:lnB w="12700" cap="flat" cmpd="sng" algn="ctr">
+                      <a:solidFill>
+                        <a:srgbClr val="DADCE0"/>
+                      </a:solidFill>
+                      <a:prstDash val="solid"/>
+                      <a:round/>
+                      <a:headEnd type="none" w="med" len="med"/>
+                      <a:tailEnd type="none" w="med" len="med"/>
+                    </a:lnB>
+                    <a:solidFill>
+                      <a:srgbClr val="FFFFFF"/>
+                    </a:solidFill>
+                  </a:tcPr>
+                </a:tc>
+                <a:tc>
+                  <a:txBody>
+                    <a:bodyPr/>
+                    <a:lstStyle/>
+                    <a:p>
+                      <a:pPr algn="l" indent="0" marL="0">
+                        <a:buNone/>
+                      </a:pPr>
+                      <a:r>
+                        <a:rPr lang="en-US" sz="1400" dirty="0">
+                          <a:solidFill>
+                            <a:srgbClr val="202124"/>
+                          </a:solidFill>
+                        </a:rPr>
+                        <a:t>https://google-photos-vague-memory-discover.vercel.app/google_form.html</a:t>
+                      </a:r>
+                      <a:endParaRPr lang="en-US" sz="1400" dirty="0"/>
+                    </a:p>
+                  </a:txBody>
+                  <a:tcPr marL="91440" marR="91440" marT="45720" marB="45720" anchor="ctr">
+                    <a:lnL w="12700" cap="flat" cmpd="sng" algn="ctr">
+                      <a:solidFill>
+                        <a:srgbClr val="DADCE0"/>
+                      </a:solidFill>
+                      <a:prstDash val="solid"/>
+                      <a:round/>
+                      <a:headEnd type="none" w="med" len="med"/>
+                      <a:tailEnd type="none" w="med" len="med"/>
+                    </a:lnL>
+                    <a:lnR w="12700" cap="flat" cmpd="sng" algn="ctr">
+                      <a:solidFill>
+                        <a:srgbClr val="DADCE0"/>
+                      </a:solidFill>
+                      <a:prstDash val="solid"/>
+                      <a:round/>
+                      <a:headEnd type="none" w="med" len="med"/>
+                      <a:tailEnd type="none" w="med" len="med"/>
+                    </a:lnR>
+                    <a:lnT w="12700" cap="flat" cmpd="sng" algn="ctr">
+                      <a:solidFill>
+                        <a:srgbClr val="DADCE0"/>
+                      </a:solidFill>
+                      <a:prstDash val="solid"/>
+                      <a:round/>
+                      <a:headEnd type="none" w="med" len="med"/>
+                      <a:tailEnd type="none" w="med" len="med"/>
+                    </a:lnT>
+                    <a:lnB w="12700" cap="flat" cmpd="sng" algn="ctr">
+                      <a:solidFill>
+                        <a:srgbClr val="DADCE0"/>
+                      </a:solidFill>
+                      <a:prstDash val="solid"/>
+                      <a:round/>
+                      <a:headEnd type="none" w="med" len="med"/>
+                      <a:tailEnd type="none" w="med" len="med"/>
+                    </a:lnB>
+                    <a:solidFill>
+                      <a:srgbClr val="FFFFFF"/>
+                    </a:solidFill>
+                  </a:tcPr>
+                </a:tc>
+                <a:tc>
+                  <a:txBody>
+                    <a:bodyPr/>
+                    <a:lstStyle/>
+                    <a:p>
+                      <a:pPr algn="l" indent="0" marL="0">
+                        <a:buNone/>
+                      </a:pPr>
+                      <a:r>
+                        <a:rPr lang="en-US" sz="1400" dirty="0">
+                          <a:solidFill>
+                            <a:srgbClr val="202124"/>
+                          </a:solidFill>
+                        </a:rPr>
+                        <a:t>LIVE FORM</a:t>
+                      </a:r>
+                      <a:endParaRPr lang="en-US" sz="1400" dirty="0"/>
+                    </a:p>
+                  </a:txBody>
+                  <a:tcPr marL="91440" marR="91440" marT="45720" marB="45720" anchor="ctr">
+                    <a:lnL w="12700" cap="flat" cmpd="sng" algn="ctr">
+                      <a:solidFill>
+                        <a:srgbClr val="DADCE0"/>
+                      </a:solidFill>
+                      <a:prstDash val="solid"/>
+                      <a:round/>
+                      <a:headEnd type="none" w="med" len="med"/>
+                      <a:tailEnd type="none" w="med" len="med"/>
+                    </a:lnL>
+                    <a:lnR w="12700" cap="flat" cmpd="sng" algn="ctr">
+                      <a:solidFill>
+                        <a:srgbClr val="DADCE0"/>
+                      </a:solidFill>
+                      <a:prstDash val="solid"/>
+                      <a:round/>
+                      <a:headEnd type="none" w="med" len="med"/>
+                      <a:tailEnd type="none" w="med" len="med"/>
+                    </a:lnR>
+                    <a:lnT w="12700" cap="flat" cmpd="sng" algn="ctr">
+                      <a:solidFill>
+                        <a:srgbClr val="DADCE0"/>
+                      </a:solidFill>
+                      <a:prstDash val="solid"/>
+                      <a:round/>
+                      <a:headEnd type="none" w="med" len="med"/>
+                      <a:tailEnd type="none" w="med" len="med"/>
+                    </a:lnT>
+                    <a:lnB w="12700" cap="flat" cmpd="sng" algn="ctr">
+                      <a:solidFill>
+                        <a:srgbClr val="DADCE0"/>
+                      </a:solidFill>
+                      <a:prstDash val="solid"/>
+                      <a:round/>
+                      <a:headEnd type="none" w="med" len="med"/>
+                      <a:tailEnd type="none" w="med" len="med"/>
+                    </a:lnB>
+                    <a:solidFill>
+                      <a:srgbClr val="FFFFFF"/>
+                    </a:solidFill>
+                  </a:tcPr>
+                </a:tc>
+              </a:tr>
+              <a:tr h="0">
+                <a:tc>
+                  <a:txBody>
+                    <a:bodyPr/>
+                    <a:lstStyle/>
+                    <a:p>
+                      <a:pPr algn="l" indent="0" marL="0">
+                        <a:buNone/>
+                      </a:pPr>
+                      <a:r>
+                        <a:rPr lang="en-US" sz="1400" dirty="0">
+                          <a:solidFill>
+                            <a:srgbClr val="202124"/>
+                          </a:solidFill>
+                        </a:rPr>
                         <a:t>GitHub Repository</a:t>
                       </a:r>
                       <a:endParaRPr lang="en-US" sz="1400" dirty="0"/>
@@ -2897,7 +3143,7 @@
                             <a:srgbClr val="202124"/>
                           </a:solidFill>
                         </a:rPr>
-                        <a:t>Public Codebase, Datasets &amp; Integration Tests</a:t>
+                        <a:t>Public Codebase, Datasets &amp; Integration Suite</a:t>
                       </a:r>
                       <a:endParaRPr lang="en-US" sz="1400" dirty="0"/>
                     </a:p>
@@ -4836,6 +5082,313 @@
                   </a:tcPr>
                 </a:tc>
               </a:tr>
+              <a:tr h="0">
+                <a:tc>
+                  <a:txBody>
+                    <a:bodyPr/>
+                    <a:lstStyle/>
+                    <a:p>
+                      <a:pPr algn="l" indent="0" marL="0">
+                        <a:buNone/>
+                      </a:pPr>
+                      <a:r>
+                        <a:rPr lang="en-US" sz="1400" dirty="0">
+                          <a:solidFill>
+                            <a:srgbClr val="202124"/>
+                          </a:solidFill>
+                        </a:rPr>
+                        <a:t>GitHub Codebase Link</a:t>
+                      </a:r>
+                      <a:endParaRPr lang="en-US" sz="1400" dirty="0"/>
+                    </a:p>
+                  </a:txBody>
+                  <a:tcPr marL="91440" marR="91440" marT="45720" marB="45720" anchor="ctr">
+                    <a:lnL w="12700" cap="flat" cmpd="sng" algn="ctr">
+                      <a:solidFill>
+                        <a:srgbClr val="DADCE0"/>
+                      </a:solidFill>
+                      <a:prstDash val="solid"/>
+                      <a:round/>
+                      <a:headEnd type="none" w="med" len="med"/>
+                      <a:tailEnd type="none" w="med" len="med"/>
+                    </a:lnL>
+                    <a:lnR w="12700" cap="flat" cmpd="sng" algn="ctr">
+                      <a:solidFill>
+                        <a:srgbClr val="DADCE0"/>
+                      </a:solidFill>
+                      <a:prstDash val="solid"/>
+                      <a:round/>
+                      <a:headEnd type="none" w="med" len="med"/>
+                      <a:tailEnd type="none" w="med" len="med"/>
+                    </a:lnR>
+                    <a:lnT w="12700" cap="flat" cmpd="sng" algn="ctr">
+                      <a:solidFill>
+                        <a:srgbClr val="DADCE0"/>
+                      </a:solidFill>
+                      <a:prstDash val="solid"/>
+                      <a:round/>
+                      <a:headEnd type="none" w="med" len="med"/>
+                      <a:tailEnd type="none" w="med" len="med"/>
+                    </a:lnT>
+                    <a:lnB w="12700" cap="flat" cmpd="sng" algn="ctr">
+                      <a:solidFill>
+                        <a:srgbClr val="DADCE0"/>
+                      </a:solidFill>
+                      <a:prstDash val="solid"/>
+                      <a:round/>
+                      <a:headEnd type="none" w="med" len="med"/>
+                      <a:tailEnd type="none" w="med" len="med"/>
+                    </a:lnB>
+                    <a:solidFill>
+                      <a:srgbClr val="FFFFFF"/>
+                    </a:solidFill>
+                  </a:tcPr>
+                </a:tc>
+                <a:tc>
+                  <a:txBody>
+                    <a:bodyPr/>
+                    <a:lstStyle/>
+                    <a:p>
+                      <a:pPr algn="l" indent="0" marL="0">
+                        <a:buNone/>
+                      </a:pPr>
+                      <a:r>
+                        <a:rPr lang="en-US" sz="1400" dirty="0">
+                          <a:solidFill>
+                            <a:srgbClr val="202124"/>
+                          </a:solidFill>
+                        </a:rPr>
+                        <a:t>Public Repository</a:t>
+                      </a:r>
+                      <a:endParaRPr lang="en-US" sz="1400" dirty="0"/>
+                    </a:p>
+                  </a:txBody>
+                  <a:tcPr marL="91440" marR="91440" marT="45720" marB="45720" anchor="ctr">
+                    <a:lnL w="12700" cap="flat" cmpd="sng" algn="ctr">
+                      <a:solidFill>
+                        <a:srgbClr val="DADCE0"/>
+                      </a:solidFill>
+                      <a:prstDash val="solid"/>
+                      <a:round/>
+                      <a:headEnd type="none" w="med" len="med"/>
+                      <a:tailEnd type="none" w="med" len="med"/>
+                    </a:lnL>
+                    <a:lnR w="12700" cap="flat" cmpd="sng" algn="ctr">
+                      <a:solidFill>
+                        <a:srgbClr val="DADCE0"/>
+                      </a:solidFill>
+                      <a:prstDash val="solid"/>
+                      <a:round/>
+                      <a:headEnd type="none" w="med" len="med"/>
+                      <a:tailEnd type="none" w="med" len="med"/>
+                    </a:lnR>
+                    <a:lnT w="12700" cap="flat" cmpd="sng" algn="ctr">
+                      <a:solidFill>
+                        <a:srgbClr val="DADCE0"/>
+                      </a:solidFill>
+                      <a:prstDash val="solid"/>
+                      <a:round/>
+                      <a:headEnd type="none" w="med" len="med"/>
+                      <a:tailEnd type="none" w="med" len="med"/>
+                    </a:lnT>
+                    <a:lnB w="12700" cap="flat" cmpd="sng" algn="ctr">
+                      <a:solidFill>
+                        <a:srgbClr val="DADCE0"/>
+                      </a:solidFill>
+                      <a:prstDash val="solid"/>
+                      <a:round/>
+                      <a:headEnd type="none" w="med" len="med"/>
+                      <a:tailEnd type="none" w="med" len="med"/>
+                    </a:lnB>
+                    <a:solidFill>
+                      <a:srgbClr val="FFFFFF"/>
+                    </a:solidFill>
+                  </a:tcPr>
+                </a:tc>
+                <a:tc>
+                  <a:txBody>
+                    <a:bodyPr/>
+                    <a:lstStyle/>
+                    <a:p>
+                      <a:pPr algn="l" indent="0" marL="0">
+                        <a:buNone/>
+                      </a:pPr>
+                      <a:r>
+                        <a:rPr lang="en-US" sz="1400" dirty="0">
+                          <a:solidFill>
+                            <a:srgbClr val="202124"/>
+                          </a:solidFill>
+                        </a:rPr>
+                        <a:t>Full Source Code &amp; Tests</a:t>
+                      </a:r>
+                      <a:endParaRPr lang="en-US" sz="1400" dirty="0"/>
+                    </a:p>
+                  </a:txBody>
+                  <a:tcPr marL="91440" marR="91440" marT="45720" marB="45720" anchor="ctr">
+                    <a:lnL w="12700" cap="flat" cmpd="sng" algn="ctr">
+                      <a:solidFill>
+                        <a:srgbClr val="DADCE0"/>
+                      </a:solidFill>
+                      <a:prstDash val="solid"/>
+                      <a:round/>
+                      <a:headEnd type="none" w="med" len="med"/>
+                      <a:tailEnd type="none" w="med" len="med"/>
+                    </a:lnL>
+                    <a:lnR w="12700" cap="flat" cmpd="sng" algn="ctr">
+                      <a:solidFill>
+                        <a:srgbClr val="DADCE0"/>
+                      </a:solidFill>
+                      <a:prstDash val="solid"/>
+                      <a:round/>
+                      <a:headEnd type="none" w="med" len="med"/>
+                      <a:tailEnd type="none" w="med" len="med"/>
+                    </a:lnR>
+                    <a:lnT w="12700" cap="flat" cmpd="sng" algn="ctr">
+                      <a:solidFill>
+                        <a:srgbClr val="DADCE0"/>
+                      </a:solidFill>
+                      <a:prstDash val="solid"/>
+                      <a:round/>
+                      <a:headEnd type="none" w="med" len="med"/>
+                      <a:tailEnd type="none" w="med" len="med"/>
+                    </a:lnT>
+                    <a:lnB w="12700" cap="flat" cmpd="sng" algn="ctr">
+                      <a:solidFill>
+                        <a:srgbClr val="DADCE0"/>
+                      </a:solidFill>
+                      <a:prstDash val="solid"/>
+                      <a:round/>
+                      <a:headEnd type="none" w="med" len="med"/>
+                      <a:tailEnd type="none" w="med" len="med"/>
+                    </a:lnB>
+                    <a:solidFill>
+                      <a:srgbClr val="FFFFFF"/>
+                    </a:solidFill>
+                  </a:tcPr>
+                </a:tc>
+                <a:tc>
+                  <a:txBody>
+                    <a:bodyPr/>
+                    <a:lstStyle/>
+                    <a:p>
+                      <a:pPr algn="l" indent="0" marL="0">
+                        <a:buNone/>
+                      </a:pPr>
+                      <a:r>
+                        <a:rPr lang="en-US" sz="1400" dirty="0">
+                          <a:solidFill>
+                            <a:srgbClr val="202124"/>
+                          </a:solidFill>
+                        </a:rPr>
+                        <a:t>https://github.com/hatakekakashi05/google-photos-vague-memory-</a:t>
+                      </a:r>
+                      <a:endParaRPr lang="en-US" sz="1400" dirty="0"/>
+                    </a:p>
+                  </a:txBody>
+                  <a:tcPr marL="91440" marR="91440" marT="45720" marB="45720" anchor="ctr">
+                    <a:lnL w="12700" cap="flat" cmpd="sng" algn="ctr">
+                      <a:solidFill>
+                        <a:srgbClr val="DADCE0"/>
+                      </a:solidFill>
+                      <a:prstDash val="solid"/>
+                      <a:round/>
+                      <a:headEnd type="none" w="med" len="med"/>
+                      <a:tailEnd type="none" w="med" len="med"/>
+                    </a:lnL>
+                    <a:lnR w="12700" cap="flat" cmpd="sng" algn="ctr">
+                      <a:solidFill>
+                        <a:srgbClr val="DADCE0"/>
+                      </a:solidFill>
+                      <a:prstDash val="solid"/>
+                      <a:round/>
+                      <a:headEnd type="none" w="med" len="med"/>
+                      <a:tailEnd type="none" w="med" len="med"/>
+                    </a:lnR>
+                    <a:lnT w="12700" cap="flat" cmpd="sng" algn="ctr">
+                      <a:solidFill>
+                        <a:srgbClr val="DADCE0"/>
+                      </a:solidFill>
+                      <a:prstDash val="solid"/>
+                      <a:round/>
+                      <a:headEnd type="none" w="med" len="med"/>
+                      <a:tailEnd type="none" w="med" len="med"/>
+                    </a:lnT>
+                    <a:lnB w="12700" cap="flat" cmpd="sng" algn="ctr">
+                      <a:solidFill>
+                        <a:srgbClr val="DADCE0"/>
+                      </a:solidFill>
+                      <a:prstDash val="solid"/>
+                      <a:round/>
+                      <a:headEnd type="none" w="med" len="med"/>
+                      <a:tailEnd type="none" w="med" len="med"/>
+                    </a:lnB>
+                    <a:solidFill>
+                      <a:srgbClr val="FFFFFF"/>
+                    </a:solidFill>
+                  </a:tcPr>
+                </a:tc>
+                <a:tc>
+                  <a:txBody>
+                    <a:bodyPr/>
+                    <a:lstStyle/>
+                    <a:p>
+                      <a:pPr algn="l" indent="0" marL="0">
+                        <a:buNone/>
+                      </a:pPr>
+                      <a:r>
+                        <a:rPr lang="en-US" sz="1400" dirty="0">
+                          <a:solidFill>
+                            <a:srgbClr val="202124"/>
+                          </a:solidFill>
+                        </a:rPr>
+                        <a:t>Production Ready</a:t>
+                      </a:r>
+                      <a:endParaRPr lang="en-US" sz="1400" dirty="0"/>
+                    </a:p>
+                  </a:txBody>
+                  <a:tcPr marL="91440" marR="91440" marT="45720" marB="45720" anchor="ctr">
+                    <a:lnL w="12700" cap="flat" cmpd="sng" algn="ctr">
+                      <a:solidFill>
+                        <a:srgbClr val="DADCE0"/>
+                      </a:solidFill>
+                      <a:prstDash val="solid"/>
+                      <a:round/>
+                      <a:headEnd type="none" w="med" len="med"/>
+                      <a:tailEnd type="none" w="med" len="med"/>
+                    </a:lnL>
+                    <a:lnR w="12700" cap="flat" cmpd="sng" algn="ctr">
+                      <a:solidFill>
+                        <a:srgbClr val="DADCE0"/>
+                      </a:solidFill>
+                      <a:prstDash val="solid"/>
+                      <a:round/>
+                      <a:headEnd type="none" w="med" len="med"/>
+                      <a:tailEnd type="none" w="med" len="med"/>
+                    </a:lnR>
+                    <a:lnT w="12700" cap="flat" cmpd="sng" algn="ctr">
+                      <a:solidFill>
+                        <a:srgbClr val="DADCE0"/>
+                      </a:solidFill>
+                      <a:prstDash val="solid"/>
+                      <a:round/>
+                      <a:headEnd type="none" w="med" len="med"/>
+                      <a:tailEnd type="none" w="med" len="med"/>
+                    </a:lnT>
+                    <a:lnB w="12700" cap="flat" cmpd="sng" algn="ctr">
+                      <a:solidFill>
+                        <a:srgbClr val="DADCE0"/>
+                      </a:solidFill>
+                      <a:prstDash val="solid"/>
+                      <a:round/>
+                      <a:headEnd type="none" w="med" len="med"/>
+                      <a:tailEnd type="none" w="med" len="med"/>
+                    </a:lnB>
+                    <a:solidFill>
+                      <a:srgbClr val="FFFFFF"/>
+                    </a:solidFill>
+                  </a:tcPr>
+                </a:tc>
+              </a:tr>
             </a:tbl>
           </a:graphicData>
         </a:graphic>
@@ -5035,7 +5588,7 @@
                   <a:srgbClr val="1A73E8"/>
                 </a:solidFill>
               </a:rPr>
-              <a:t>Canonical North-Star Metric Tree Architecture</a:t>
+              <a:t>Canonical North-Star Metric Tree Architecture &amp; Empirical Lift Targets</a:t>
             </a:r>
             <a:endParaRPr lang="en-US" sz="1500" dirty="0"/>
           </a:p>
@@ -5207,7 +5760,7 @@
                             <a:srgbClr val="1A73E8"/>
                           </a:solidFill>
                         </a:rPr>
-                        <a:t>Baseline / Target</a:t>
+                        <a:t>Baseline → Target</a:t>
                       </a:r>
                       <a:endParaRPr lang="en-US" sz="1400" dirty="0"/>
                     </a:p>
@@ -5636,7 +6189,7 @@
                             <a:srgbClr val="202124"/>
                           </a:solidFill>
                         </a:rPr>
-                        <a:t>Primary Impact</a:t>
+                        <a:t>Primary Lift</a:t>
                       </a:r>
                       <a:endParaRPr lang="en-US" sz="1400" dirty="0"/>
                     </a:p>
@@ -5882,7 +6435,7 @@
                             <a:srgbClr val="202124"/>
                           </a:solidFill>
                         </a:rPr>
-                        <a:t>Surfaced Candidate Anchors / Total Vague Query Sessions</a:t>
+                        <a:t>Surfaced Candidate Anchors (K=5) / Total Vague Query Sessions</a:t>
                       </a:r>
                       <a:endParaRPr lang="en-US" sz="1400" dirty="0"/>
                     </a:p>
@@ -6189,7 +6742,7 @@
                             <a:srgbClr val="202124"/>
                           </a:solidFill>
                         </a:rPr>
-                        <a:t>Target Media Found in Context / Surfaced Anchor Sessions</a:t>
+                        <a:t>Target Media Found in Context (±4h, ≤1km) / Anchor Sessions</a:t>
                       </a:r>
                       <a:endParaRPr lang="en-US" sz="1400" dirty="0"/>
                     </a:p>
@@ -6313,7 +6866,7 @@
                             <a:srgbClr val="202124"/>
                           </a:solidFill>
                         </a:rPr>
-                        <a:t>Guardrail Metric</a:t>
+                        <a:t>Guardrail Metric 1</a:t>
                       </a:r>
                       <a:endParaRPr lang="en-US" sz="1400" dirty="0"/>
                     </a:p>
@@ -6496,7 +7049,7 @@
                             <a:srgbClr val="202124"/>
                           </a:solidFill>
                         </a:rPr>
-                        <a:t>Search Sessions Abandoned between 1 to 3 minutes of timeline scrolling</a:t>
+                        <a:t>Search Sessions Abandoned after 1 to 3 minutes of timeline scrolling</a:t>
                       </a:r>
                       <a:endParaRPr lang="en-US" sz="1400" dirty="0"/>
                     </a:p>
@@ -6558,6 +7111,313 @@
                           </a:solidFill>
                         </a:rPr>
                         <a:t>Friction Reducer</a:t>
+                      </a:r>
+                      <a:endParaRPr lang="en-US" sz="1400" dirty="0"/>
+                    </a:p>
+                  </a:txBody>
+                  <a:tcPr marL="91440" marR="91440" marT="45720" marB="45720" anchor="ctr">
+                    <a:lnL w="12700" cap="flat" cmpd="sng" algn="ctr">
+                      <a:solidFill>
+                        <a:srgbClr val="DADCE0"/>
+                      </a:solidFill>
+                      <a:prstDash val="solid"/>
+                      <a:round/>
+                      <a:headEnd type="none" w="med" len="med"/>
+                      <a:tailEnd type="none" w="med" len="med"/>
+                    </a:lnL>
+                    <a:lnR w="12700" cap="flat" cmpd="sng" algn="ctr">
+                      <a:solidFill>
+                        <a:srgbClr val="DADCE0"/>
+                      </a:solidFill>
+                      <a:prstDash val="solid"/>
+                      <a:round/>
+                      <a:headEnd type="none" w="med" len="med"/>
+                      <a:tailEnd type="none" w="med" len="med"/>
+                    </a:lnR>
+                    <a:lnT w="12700" cap="flat" cmpd="sng" algn="ctr">
+                      <a:solidFill>
+                        <a:srgbClr val="DADCE0"/>
+                      </a:solidFill>
+                      <a:prstDash val="solid"/>
+                      <a:round/>
+                      <a:headEnd type="none" w="med" len="med"/>
+                      <a:tailEnd type="none" w="med" len="med"/>
+                    </a:lnT>
+                    <a:lnB w="12700" cap="flat" cmpd="sng" algn="ctr">
+                      <a:solidFill>
+                        <a:srgbClr val="DADCE0"/>
+                      </a:solidFill>
+                      <a:prstDash val="solid"/>
+                      <a:round/>
+                      <a:headEnd type="none" w="med" len="med"/>
+                      <a:tailEnd type="none" w="med" len="med"/>
+                    </a:lnB>
+                    <a:solidFill>
+                      <a:srgbClr val="FFFFFF"/>
+                    </a:solidFill>
+                  </a:tcPr>
+                </a:tc>
+              </a:tr>
+              <a:tr h="0">
+                <a:tc>
+                  <a:txBody>
+                    <a:bodyPr/>
+                    <a:lstStyle/>
+                    <a:p>
+                      <a:pPr algn="l" indent="0" marL="0">
+                        <a:buNone/>
+                      </a:pPr>
+                      <a:r>
+                        <a:rPr lang="en-US" sz="1400" dirty="0">
+                          <a:solidFill>
+                            <a:srgbClr val="202124"/>
+                          </a:solidFill>
+                        </a:rPr>
+                        <a:t>Guardrail Metric 2</a:t>
+                      </a:r>
+                      <a:endParaRPr lang="en-US" sz="1400" dirty="0"/>
+                    </a:p>
+                  </a:txBody>
+                  <a:tcPr marL="91440" marR="91440" marT="45720" marB="45720" anchor="ctr">
+                    <a:lnL w="12700" cap="flat" cmpd="sng" algn="ctr">
+                      <a:solidFill>
+                        <a:srgbClr val="DADCE0"/>
+                      </a:solidFill>
+                      <a:prstDash val="solid"/>
+                      <a:round/>
+                      <a:headEnd type="none" w="med" len="med"/>
+                      <a:tailEnd type="none" w="med" len="med"/>
+                    </a:lnL>
+                    <a:lnR w="12700" cap="flat" cmpd="sng" algn="ctr">
+                      <a:solidFill>
+                        <a:srgbClr val="DADCE0"/>
+                      </a:solidFill>
+                      <a:prstDash val="solid"/>
+                      <a:round/>
+                      <a:headEnd type="none" w="med" len="med"/>
+                      <a:tailEnd type="none" w="med" len="med"/>
+                    </a:lnR>
+                    <a:lnT w="12700" cap="flat" cmpd="sng" algn="ctr">
+                      <a:solidFill>
+                        <a:srgbClr val="DADCE0"/>
+                      </a:solidFill>
+                      <a:prstDash val="solid"/>
+                      <a:round/>
+                      <a:headEnd type="none" w="med" len="med"/>
+                      <a:tailEnd type="none" w="med" len="med"/>
+                    </a:lnT>
+                    <a:lnB w="12700" cap="flat" cmpd="sng" algn="ctr">
+                      <a:solidFill>
+                        <a:srgbClr val="DADCE0"/>
+                      </a:solidFill>
+                      <a:prstDash val="solid"/>
+                      <a:round/>
+                      <a:headEnd type="none" w="med" len="med"/>
+                      <a:tailEnd type="none" w="med" len="med"/>
+                    </a:lnB>
+                    <a:solidFill>
+                      <a:srgbClr val="FFFFFF"/>
+                    </a:solidFill>
+                  </a:tcPr>
+                </a:tc>
+                <a:tc>
+                  <a:txBody>
+                    <a:bodyPr/>
+                    <a:lstStyle/>
+                    <a:p>
+                      <a:pPr algn="l" indent="0" marL="0">
+                        <a:buNone/>
+                      </a:pPr>
+                      <a:r>
+                        <a:rPr lang="en-US" sz="1400" dirty="0">
+                          <a:solidFill>
+                            <a:srgbClr val="202124"/>
+                          </a:solidFill>
+                        </a:rPr>
+                        <a:t>API End-to-End Latency</a:t>
+                      </a:r>
+                      <a:endParaRPr lang="en-US" sz="1400" dirty="0"/>
+                    </a:p>
+                  </a:txBody>
+                  <a:tcPr marL="91440" marR="91440" marT="45720" marB="45720" anchor="ctr">
+                    <a:lnL w="12700" cap="flat" cmpd="sng" algn="ctr">
+                      <a:solidFill>
+                        <a:srgbClr val="DADCE0"/>
+                      </a:solidFill>
+                      <a:prstDash val="solid"/>
+                      <a:round/>
+                      <a:headEnd type="none" w="med" len="med"/>
+                      <a:tailEnd type="none" w="med" len="med"/>
+                    </a:lnL>
+                    <a:lnR w="12700" cap="flat" cmpd="sng" algn="ctr">
+                      <a:solidFill>
+                        <a:srgbClr val="DADCE0"/>
+                      </a:solidFill>
+                      <a:prstDash val="solid"/>
+                      <a:round/>
+                      <a:headEnd type="none" w="med" len="med"/>
+                      <a:tailEnd type="none" w="med" len="med"/>
+                    </a:lnR>
+                    <a:lnT w="12700" cap="flat" cmpd="sng" algn="ctr">
+                      <a:solidFill>
+                        <a:srgbClr val="DADCE0"/>
+                      </a:solidFill>
+                      <a:prstDash val="solid"/>
+                      <a:round/>
+                      <a:headEnd type="none" w="med" len="med"/>
+                      <a:tailEnd type="none" w="med" len="med"/>
+                    </a:lnT>
+                    <a:lnB w="12700" cap="flat" cmpd="sng" algn="ctr">
+                      <a:solidFill>
+                        <a:srgbClr val="DADCE0"/>
+                      </a:solidFill>
+                      <a:prstDash val="solid"/>
+                      <a:round/>
+                      <a:headEnd type="none" w="med" len="med"/>
+                      <a:tailEnd type="none" w="med" len="med"/>
+                    </a:lnB>
+                    <a:solidFill>
+                      <a:srgbClr val="FFFFFF"/>
+                    </a:solidFill>
+                  </a:tcPr>
+                </a:tc>
+                <a:tc>
+                  <a:txBody>
+                    <a:bodyPr/>
+                    <a:lstStyle/>
+                    <a:p>
+                      <a:pPr algn="l" indent="0" marL="0">
+                        <a:buNone/>
+                      </a:pPr>
+                      <a:r>
+                        <a:rPr lang="en-US" sz="1400" dirty="0">
+                          <a:solidFill>
+                            <a:srgbClr val="202124"/>
+                          </a:solidFill>
+                        </a:rPr>
+                        <a:t>&lt; 250ms Target</a:t>
+                      </a:r>
+                      <a:endParaRPr lang="en-US" sz="1400" dirty="0"/>
+                    </a:p>
+                  </a:txBody>
+                  <a:tcPr marL="91440" marR="91440" marT="45720" marB="45720" anchor="ctr">
+                    <a:lnL w="12700" cap="flat" cmpd="sng" algn="ctr">
+                      <a:solidFill>
+                        <a:srgbClr val="DADCE0"/>
+                      </a:solidFill>
+                      <a:prstDash val="solid"/>
+                      <a:round/>
+                      <a:headEnd type="none" w="med" len="med"/>
+                      <a:tailEnd type="none" w="med" len="med"/>
+                    </a:lnL>
+                    <a:lnR w="12700" cap="flat" cmpd="sng" algn="ctr">
+                      <a:solidFill>
+                        <a:srgbClr val="DADCE0"/>
+                      </a:solidFill>
+                      <a:prstDash val="solid"/>
+                      <a:round/>
+                      <a:headEnd type="none" w="med" len="med"/>
+                      <a:tailEnd type="none" w="med" len="med"/>
+                    </a:lnR>
+                    <a:lnT w="12700" cap="flat" cmpd="sng" algn="ctr">
+                      <a:solidFill>
+                        <a:srgbClr val="DADCE0"/>
+                      </a:solidFill>
+                      <a:prstDash val="solid"/>
+                      <a:round/>
+                      <a:headEnd type="none" w="med" len="med"/>
+                      <a:tailEnd type="none" w="med" len="med"/>
+                    </a:lnT>
+                    <a:lnB w="12700" cap="flat" cmpd="sng" algn="ctr">
+                      <a:solidFill>
+                        <a:srgbClr val="DADCE0"/>
+                      </a:solidFill>
+                      <a:prstDash val="solid"/>
+                      <a:round/>
+                      <a:headEnd type="none" w="med" len="med"/>
+                      <a:tailEnd type="none" w="med" len="med"/>
+                    </a:lnB>
+                    <a:solidFill>
+                      <a:srgbClr val="FFFFFF"/>
+                    </a:solidFill>
+                  </a:tcPr>
+                </a:tc>
+                <a:tc>
+                  <a:txBody>
+                    <a:bodyPr/>
+                    <a:lstStyle/>
+                    <a:p>
+                      <a:pPr algn="l" indent="0" marL="0">
+                        <a:buNone/>
+                      </a:pPr>
+                      <a:r>
+                        <a:rPr lang="en-US" sz="1400" dirty="0">
+                          <a:solidFill>
+                            <a:srgbClr val="202124"/>
+                          </a:solidFill>
+                        </a:rPr>
+                        <a:t>Total Milliseconds from Query Submission to Context Grid Render</a:t>
+                      </a:r>
+                      <a:endParaRPr lang="en-US" sz="1400" dirty="0"/>
+                    </a:p>
+                  </a:txBody>
+                  <a:tcPr marL="91440" marR="91440" marT="45720" marB="45720" anchor="ctr">
+                    <a:lnL w="12700" cap="flat" cmpd="sng" algn="ctr">
+                      <a:solidFill>
+                        <a:srgbClr val="DADCE0"/>
+                      </a:solidFill>
+                      <a:prstDash val="solid"/>
+                      <a:round/>
+                      <a:headEnd type="none" w="med" len="med"/>
+                      <a:tailEnd type="none" w="med" len="med"/>
+                    </a:lnL>
+                    <a:lnR w="12700" cap="flat" cmpd="sng" algn="ctr">
+                      <a:solidFill>
+                        <a:srgbClr val="DADCE0"/>
+                      </a:solidFill>
+                      <a:prstDash val="solid"/>
+                      <a:round/>
+                      <a:headEnd type="none" w="med" len="med"/>
+                      <a:tailEnd type="none" w="med" len="med"/>
+                    </a:lnR>
+                    <a:lnT w="12700" cap="flat" cmpd="sng" algn="ctr">
+                      <a:solidFill>
+                        <a:srgbClr val="DADCE0"/>
+                      </a:solidFill>
+                      <a:prstDash val="solid"/>
+                      <a:round/>
+                      <a:headEnd type="none" w="med" len="med"/>
+                      <a:tailEnd type="none" w="med" len="med"/>
+                    </a:lnT>
+                    <a:lnB w="12700" cap="flat" cmpd="sng" algn="ctr">
+                      <a:solidFill>
+                        <a:srgbClr val="DADCE0"/>
+                      </a:solidFill>
+                      <a:prstDash val="solid"/>
+                      <a:round/>
+                      <a:headEnd type="none" w="med" len="med"/>
+                      <a:tailEnd type="none" w="med" len="med"/>
+                    </a:lnB>
+                    <a:solidFill>
+                      <a:srgbClr val="FFFFFF"/>
+                    </a:solidFill>
+                  </a:tcPr>
+                </a:tc>
+                <a:tc>
+                  <a:txBody>
+                    <a:bodyPr/>
+                    <a:lstStyle/>
+                    <a:p>
+                      <a:pPr algn="l" indent="0" marL="0">
+                        <a:buNone/>
+                      </a:pPr>
+                      <a:r>
+                        <a:rPr lang="en-US" sz="1400" dirty="0">
+                          <a:solidFill>
+                            <a:srgbClr val="202124"/>
+                          </a:solidFill>
+                        </a:rPr>
+                        <a:t>Performance</a:t>
                       </a:r>
                       <a:endParaRPr lang="en-US" sz="1400" dirty="0"/>
                     </a:p>
@@ -6804,7 +7664,7 @@
                   <a:srgbClr val="1A73E8"/>
                 </a:solidFill>
               </a:rPr>
-              <a:t>Multi-Platform Public Community Feedback Analytics</a:t>
+              <a:t>Multi-Platform Public Community Feedback Analytics &amp; Gemini AI Synthesis</a:t>
             </a:r>
             <a:endParaRPr lang="en-US" sz="1500" dirty="0"/>
           </a:p>
@@ -8327,6 +9187,313 @@
                           </a:solidFill>
                         </a:rPr>
                         <a:t>Linear timeline search degradation</a:t>
+                      </a:r>
+                      <a:endParaRPr lang="en-US" sz="1400" dirty="0"/>
+                    </a:p>
+                  </a:txBody>
+                  <a:tcPr marL="91440" marR="91440" marT="45720" marB="45720" anchor="ctr">
+                    <a:lnL w="12700" cap="flat" cmpd="sng" algn="ctr">
+                      <a:solidFill>
+                        <a:srgbClr val="DADCE0"/>
+                      </a:solidFill>
+                      <a:prstDash val="solid"/>
+                      <a:round/>
+                      <a:headEnd type="none" w="med" len="med"/>
+                      <a:tailEnd type="none" w="med" len="med"/>
+                    </a:lnL>
+                    <a:lnR w="12700" cap="flat" cmpd="sng" algn="ctr">
+                      <a:solidFill>
+                        <a:srgbClr val="DADCE0"/>
+                      </a:solidFill>
+                      <a:prstDash val="solid"/>
+                      <a:round/>
+                      <a:headEnd type="none" w="med" len="med"/>
+                      <a:tailEnd type="none" w="med" len="med"/>
+                    </a:lnR>
+                    <a:lnT w="12700" cap="flat" cmpd="sng" algn="ctr">
+                      <a:solidFill>
+                        <a:srgbClr val="DADCE0"/>
+                      </a:solidFill>
+                      <a:prstDash val="solid"/>
+                      <a:round/>
+                      <a:headEnd type="none" w="med" len="med"/>
+                      <a:tailEnd type="none" w="med" len="med"/>
+                    </a:lnT>
+                    <a:lnB w="12700" cap="flat" cmpd="sng" algn="ctr">
+                      <a:solidFill>
+                        <a:srgbClr val="DADCE0"/>
+                      </a:solidFill>
+                      <a:prstDash val="solid"/>
+                      <a:round/>
+                      <a:headEnd type="none" w="med" len="med"/>
+                      <a:tailEnd type="none" w="med" len="med"/>
+                    </a:lnB>
+                    <a:solidFill>
+                      <a:srgbClr val="FFFFFF"/>
+                    </a:solidFill>
+                  </a:tcPr>
+                </a:tc>
+              </a:tr>
+              <a:tr h="0">
+                <a:tc>
+                  <a:txBody>
+                    <a:bodyPr/>
+                    <a:lstStyle/>
+                    <a:p>
+                      <a:pPr algn="l" indent="0" marL="0">
+                        <a:buNone/>
+                      </a:pPr>
+                      <a:r>
+                        <a:rPr lang="en-US" sz="1400" dirty="0">
+                          <a:solidFill>
+                            <a:srgbClr val="202124"/>
+                          </a:solidFill>
+                        </a:rPr>
+                        <a:t>Discovery Engine Link</a:t>
+                      </a:r>
+                      <a:endParaRPr lang="en-US" sz="1400" dirty="0"/>
+                    </a:p>
+                  </a:txBody>
+                  <a:tcPr marL="91440" marR="91440" marT="45720" marB="45720" anchor="ctr">
+                    <a:lnL w="12700" cap="flat" cmpd="sng" algn="ctr">
+                      <a:solidFill>
+                        <a:srgbClr val="DADCE0"/>
+                      </a:solidFill>
+                      <a:prstDash val="solid"/>
+                      <a:round/>
+                      <a:headEnd type="none" w="med" len="med"/>
+                      <a:tailEnd type="none" w="med" len="med"/>
+                    </a:lnL>
+                    <a:lnR w="12700" cap="flat" cmpd="sng" algn="ctr">
+                      <a:solidFill>
+                        <a:srgbClr val="DADCE0"/>
+                      </a:solidFill>
+                      <a:prstDash val="solid"/>
+                      <a:round/>
+                      <a:headEnd type="none" w="med" len="med"/>
+                      <a:tailEnd type="none" w="med" len="med"/>
+                    </a:lnR>
+                    <a:lnT w="12700" cap="flat" cmpd="sng" algn="ctr">
+                      <a:solidFill>
+                        <a:srgbClr val="DADCE0"/>
+                      </a:solidFill>
+                      <a:prstDash val="solid"/>
+                      <a:round/>
+                      <a:headEnd type="none" w="med" len="med"/>
+                      <a:tailEnd type="none" w="med" len="med"/>
+                    </a:lnT>
+                    <a:lnB w="12700" cap="flat" cmpd="sng" algn="ctr">
+                      <a:solidFill>
+                        <a:srgbClr val="DADCE0"/>
+                      </a:solidFill>
+                      <a:prstDash val="solid"/>
+                      <a:round/>
+                      <a:headEnd type="none" w="med" len="med"/>
+                      <a:tailEnd type="none" w="med" len="med"/>
+                    </a:lnB>
+                    <a:solidFill>
+                      <a:srgbClr val="FFFFFF"/>
+                    </a:solidFill>
+                  </a:tcPr>
+                </a:tc>
+                <a:tc>
+                  <a:txBody>
+                    <a:bodyPr/>
+                    <a:lstStyle/>
+                    <a:p>
+                      <a:pPr algn="l" indent="0" marL="0">
+                        <a:buNone/>
+                      </a:pPr>
+                      <a:r>
+                        <a:rPr lang="en-US" sz="1400" dirty="0">
+                          <a:solidFill>
+                            <a:srgbClr val="202124"/>
+                          </a:solidFill>
+                        </a:rPr>
+                        <a:t>Live Dashboard</a:t>
+                      </a:r>
+                      <a:endParaRPr lang="en-US" sz="1400" dirty="0"/>
+                    </a:p>
+                  </a:txBody>
+                  <a:tcPr marL="91440" marR="91440" marT="45720" marB="45720" anchor="ctr">
+                    <a:lnL w="12700" cap="flat" cmpd="sng" algn="ctr">
+                      <a:solidFill>
+                        <a:srgbClr val="DADCE0"/>
+                      </a:solidFill>
+                      <a:prstDash val="solid"/>
+                      <a:round/>
+                      <a:headEnd type="none" w="med" len="med"/>
+                      <a:tailEnd type="none" w="med" len="med"/>
+                    </a:lnL>
+                    <a:lnR w="12700" cap="flat" cmpd="sng" algn="ctr">
+                      <a:solidFill>
+                        <a:srgbClr val="DADCE0"/>
+                      </a:solidFill>
+                      <a:prstDash val="solid"/>
+                      <a:round/>
+                      <a:headEnd type="none" w="med" len="med"/>
+                      <a:tailEnd type="none" w="med" len="med"/>
+                    </a:lnR>
+                    <a:lnT w="12700" cap="flat" cmpd="sng" algn="ctr">
+                      <a:solidFill>
+                        <a:srgbClr val="DADCE0"/>
+                      </a:solidFill>
+                      <a:prstDash val="solid"/>
+                      <a:round/>
+                      <a:headEnd type="none" w="med" len="med"/>
+                      <a:tailEnd type="none" w="med" len="med"/>
+                    </a:lnT>
+                    <a:lnB w="12700" cap="flat" cmpd="sng" algn="ctr">
+                      <a:solidFill>
+                        <a:srgbClr val="DADCE0"/>
+                      </a:solidFill>
+                      <a:prstDash val="solid"/>
+                      <a:round/>
+                      <a:headEnd type="none" w="med" len="med"/>
+                      <a:tailEnd type="none" w="med" len="med"/>
+                    </a:lnB>
+                    <a:solidFill>
+                      <a:srgbClr val="FFFFFF"/>
+                    </a:solidFill>
+                  </a:tcPr>
+                </a:tc>
+                <a:tc>
+                  <a:txBody>
+                    <a:bodyPr/>
+                    <a:lstStyle/>
+                    <a:p>
+                      <a:pPr algn="l" indent="0" marL="0">
+                        <a:buNone/>
+                      </a:pPr>
+                      <a:r>
+                        <a:rPr lang="en-US" sz="1400" dirty="0">
+                          <a:solidFill>
+                            <a:srgbClr val="202124"/>
+                          </a:solidFill>
+                        </a:rPr>
+                        <a:t>1,000 Reviews</a:t>
+                      </a:r>
+                      <a:endParaRPr lang="en-US" sz="1400" dirty="0"/>
+                    </a:p>
+                  </a:txBody>
+                  <a:tcPr marL="91440" marR="91440" marT="45720" marB="45720" anchor="ctr">
+                    <a:lnL w="12700" cap="flat" cmpd="sng" algn="ctr">
+                      <a:solidFill>
+                        <a:srgbClr val="DADCE0"/>
+                      </a:solidFill>
+                      <a:prstDash val="solid"/>
+                      <a:round/>
+                      <a:headEnd type="none" w="med" len="med"/>
+                      <a:tailEnd type="none" w="med" len="med"/>
+                    </a:lnL>
+                    <a:lnR w="12700" cap="flat" cmpd="sng" algn="ctr">
+                      <a:solidFill>
+                        <a:srgbClr val="DADCE0"/>
+                      </a:solidFill>
+                      <a:prstDash val="solid"/>
+                      <a:round/>
+                      <a:headEnd type="none" w="med" len="med"/>
+                      <a:tailEnd type="none" w="med" len="med"/>
+                    </a:lnR>
+                    <a:lnT w="12700" cap="flat" cmpd="sng" algn="ctr">
+                      <a:solidFill>
+                        <a:srgbClr val="DADCE0"/>
+                      </a:solidFill>
+                      <a:prstDash val="solid"/>
+                      <a:round/>
+                      <a:headEnd type="none" w="med" len="med"/>
+                      <a:tailEnd type="none" w="med" len="med"/>
+                    </a:lnT>
+                    <a:lnB w="12700" cap="flat" cmpd="sng" algn="ctr">
+                      <a:solidFill>
+                        <a:srgbClr val="DADCE0"/>
+                      </a:solidFill>
+                      <a:prstDash val="solid"/>
+                      <a:round/>
+                      <a:headEnd type="none" w="med" len="med"/>
+                      <a:tailEnd type="none" w="med" len="med"/>
+                    </a:lnB>
+                    <a:solidFill>
+                      <a:srgbClr val="FFFFFF"/>
+                    </a:solidFill>
+                  </a:tcPr>
+                </a:tc>
+                <a:tc>
+                  <a:txBody>
+                    <a:bodyPr/>
+                    <a:lstStyle/>
+                    <a:p>
+                      <a:pPr algn="l" indent="0" marL="0">
+                        <a:buNone/>
+                      </a:pPr>
+                      <a:r>
+                        <a:rPr lang="en-US" sz="1400" dirty="0">
+                          <a:solidFill>
+                            <a:srgbClr val="202124"/>
+                          </a:solidFill>
+                        </a:rPr>
+                        <a:t>https://google-photos-vague-memory-discover.vercel.app/</a:t>
+                      </a:r>
+                      <a:endParaRPr lang="en-US" sz="1400" dirty="0"/>
+                    </a:p>
+                  </a:txBody>
+                  <a:tcPr marL="91440" marR="91440" marT="45720" marB="45720" anchor="ctr">
+                    <a:lnL w="12700" cap="flat" cmpd="sng" algn="ctr">
+                      <a:solidFill>
+                        <a:srgbClr val="DADCE0"/>
+                      </a:solidFill>
+                      <a:prstDash val="solid"/>
+                      <a:round/>
+                      <a:headEnd type="none" w="med" len="med"/>
+                      <a:tailEnd type="none" w="med" len="med"/>
+                    </a:lnL>
+                    <a:lnR w="12700" cap="flat" cmpd="sng" algn="ctr">
+                      <a:solidFill>
+                        <a:srgbClr val="DADCE0"/>
+                      </a:solidFill>
+                      <a:prstDash val="solid"/>
+                      <a:round/>
+                      <a:headEnd type="none" w="med" len="med"/>
+                      <a:tailEnd type="none" w="med" len="med"/>
+                    </a:lnR>
+                    <a:lnT w="12700" cap="flat" cmpd="sng" algn="ctr">
+                      <a:solidFill>
+                        <a:srgbClr val="DADCE0"/>
+                      </a:solidFill>
+                      <a:prstDash val="solid"/>
+                      <a:round/>
+                      <a:headEnd type="none" w="med" len="med"/>
+                      <a:tailEnd type="none" w="med" len="med"/>
+                    </a:lnT>
+                    <a:lnB w="12700" cap="flat" cmpd="sng" algn="ctr">
+                      <a:solidFill>
+                        <a:srgbClr val="DADCE0"/>
+                      </a:solidFill>
+                      <a:prstDash val="solid"/>
+                      <a:round/>
+                      <a:headEnd type="none" w="med" len="med"/>
+                      <a:tailEnd type="none" w="med" len="med"/>
+                    </a:lnB>
+                    <a:solidFill>
+                      <a:srgbClr val="FFFFFF"/>
+                    </a:solidFill>
+                  </a:tcPr>
+                </a:tc>
+                <a:tc>
+                  <a:txBody>
+                    <a:bodyPr/>
+                    <a:lstStyle/>
+                    <a:p>
+                      <a:pPr algn="l" indent="0" marL="0">
+                        <a:buNone/>
+                      </a:pPr>
+                      <a:r>
+                        <a:rPr lang="en-US" sz="1400" dirty="0">
+                          <a:solidFill>
+                            <a:srgbClr val="202124"/>
+                          </a:solidFill>
+                        </a:rPr>
+                        <a:t>Real-Time Gemini Synthesis</a:t>
                       </a:r>
                       <a:endParaRPr lang="en-US" sz="1400" dirty="0"/>
                     </a:p>
@@ -8805,7 +9972,7 @@
                             <a:srgbClr val="1A73E8"/>
                           </a:solidFill>
                         </a:rPr>
-                        <a:t>Observed User Retrieval Behavior</a:t>
+                        <a:t>Observed User Behavior &amp; Resource Link</a:t>
                       </a:r>
                       <a:endParaRPr lang="en-US" sz="1400" dirty="0"/>
                     </a:p>
@@ -9790,6 +10957,252 @@
                           </a:solidFill>
                         </a:rPr>
                         <a:t>Time-sensitive tax, warranty, and expense reimbursement filings</a:t>
+                      </a:r>
+                      <a:endParaRPr lang="en-US" sz="1400" dirty="0"/>
+                    </a:p>
+                  </a:txBody>
+                  <a:tcPr marL="91440" marR="91440" marT="45720" marB="45720" anchor="ctr">
+                    <a:lnL w="12700" cap="flat" cmpd="sng" algn="ctr">
+                      <a:solidFill>
+                        <a:srgbClr val="DADCE0"/>
+                      </a:solidFill>
+                      <a:prstDash val="solid"/>
+                      <a:round/>
+                      <a:headEnd type="none" w="med" len="med"/>
+                      <a:tailEnd type="none" w="med" len="med"/>
+                    </a:lnL>
+                    <a:lnR w="12700" cap="flat" cmpd="sng" algn="ctr">
+                      <a:solidFill>
+                        <a:srgbClr val="DADCE0"/>
+                      </a:solidFill>
+                      <a:prstDash val="solid"/>
+                      <a:round/>
+                      <a:headEnd type="none" w="med" len="med"/>
+                      <a:tailEnd type="none" w="med" len="med"/>
+                    </a:lnR>
+                    <a:lnT w="12700" cap="flat" cmpd="sng" algn="ctr">
+                      <a:solidFill>
+                        <a:srgbClr val="DADCE0"/>
+                      </a:solidFill>
+                      <a:prstDash val="solid"/>
+                      <a:round/>
+                      <a:headEnd type="none" w="med" len="med"/>
+                      <a:tailEnd type="none" w="med" len="med"/>
+                    </a:lnT>
+                    <a:lnB w="12700" cap="flat" cmpd="sng" algn="ctr">
+                      <a:solidFill>
+                        <a:srgbClr val="DADCE0"/>
+                      </a:solidFill>
+                      <a:prstDash val="solid"/>
+                      <a:round/>
+                      <a:headEnd type="none" w="med" len="med"/>
+                      <a:tailEnd type="none" w="med" len="med"/>
+                    </a:lnB>
+                    <a:solidFill>
+                      <a:srgbClr val="FFFFFF"/>
+                    </a:solidFill>
+                  </a:tcPr>
+                </a:tc>
+              </a:tr>
+              <a:tr h="0">
+                <a:tc>
+                  <a:txBody>
+                    <a:bodyPr/>
+                    <a:lstStyle/>
+                    <a:p>
+                      <a:pPr algn="l" indent="0" marL="0">
+                        <a:buNone/>
+                      </a:pPr>
+                      <a:r>
+                        <a:rPr lang="en-US" sz="1400" dirty="0">
+                          <a:solidFill>
+                            <a:srgbClr val="202124"/>
+                          </a:solidFill>
+                        </a:rPr>
+                        <a:t>User Survey Datasheet</a:t>
+                      </a:r>
+                      <a:endParaRPr lang="en-US" sz="1400" dirty="0"/>
+                    </a:p>
+                  </a:txBody>
+                  <a:tcPr marL="91440" marR="91440" marT="45720" marB="45720" anchor="ctr">
+                    <a:lnL w="12700" cap="flat" cmpd="sng" algn="ctr">
+                      <a:solidFill>
+                        <a:srgbClr val="DADCE0"/>
+                      </a:solidFill>
+                      <a:prstDash val="solid"/>
+                      <a:round/>
+                      <a:headEnd type="none" w="med" len="med"/>
+                      <a:tailEnd type="none" w="med" len="med"/>
+                    </a:lnL>
+                    <a:lnR w="12700" cap="flat" cmpd="sng" algn="ctr">
+                      <a:solidFill>
+                        <a:srgbClr val="DADCE0"/>
+                      </a:solidFill>
+                      <a:prstDash val="solid"/>
+                      <a:round/>
+                      <a:headEnd type="none" w="med" len="med"/>
+                      <a:tailEnd type="none" w="med" len="med"/>
+                    </a:lnR>
+                    <a:lnT w="12700" cap="flat" cmpd="sng" algn="ctr">
+                      <a:solidFill>
+                        <a:srgbClr val="DADCE0"/>
+                      </a:solidFill>
+                      <a:prstDash val="solid"/>
+                      <a:round/>
+                      <a:headEnd type="none" w="med" len="med"/>
+                      <a:tailEnd type="none" w="med" len="med"/>
+                    </a:lnT>
+                    <a:lnB w="12700" cap="flat" cmpd="sng" algn="ctr">
+                      <a:solidFill>
+                        <a:srgbClr val="DADCE0"/>
+                      </a:solidFill>
+                      <a:prstDash val="solid"/>
+                      <a:round/>
+                      <a:headEnd type="none" w="med" len="med"/>
+                      <a:tailEnd type="none" w="med" len="med"/>
+                    </a:lnB>
+                    <a:solidFill>
+                      <a:srgbClr val="FFFFFF"/>
+                    </a:solidFill>
+                  </a:tcPr>
+                </a:tc>
+                <a:tc>
+                  <a:txBody>
+                    <a:bodyPr/>
+                    <a:lstStyle/>
+                    <a:p>
+                      <a:pPr algn="l" indent="0" marL="0">
+                        <a:buNone/>
+                      </a:pPr>
+                      <a:r>
+                        <a:rPr lang="en-US" sz="1400" dirty="0">
+                          <a:solidFill>
+                            <a:srgbClr val="202124"/>
+                          </a:solidFill>
+                        </a:rPr>
+                        <a:t>Raw N=34 Google Sheet Data</a:t>
+                      </a:r>
+                      <a:endParaRPr lang="en-US" sz="1400" dirty="0"/>
+                    </a:p>
+                  </a:txBody>
+                  <a:tcPr marL="91440" marR="91440" marT="45720" marB="45720" anchor="ctr">
+                    <a:lnL w="12700" cap="flat" cmpd="sng" algn="ctr">
+                      <a:solidFill>
+                        <a:srgbClr val="DADCE0"/>
+                      </a:solidFill>
+                      <a:prstDash val="solid"/>
+                      <a:round/>
+                      <a:headEnd type="none" w="med" len="med"/>
+                      <a:tailEnd type="none" w="med" len="med"/>
+                    </a:lnL>
+                    <a:lnR w="12700" cap="flat" cmpd="sng" algn="ctr">
+                      <a:solidFill>
+                        <a:srgbClr val="DADCE0"/>
+                      </a:solidFill>
+                      <a:prstDash val="solid"/>
+                      <a:round/>
+                      <a:headEnd type="none" w="med" len="med"/>
+                      <a:tailEnd type="none" w="med" len="med"/>
+                    </a:lnR>
+                    <a:lnT w="12700" cap="flat" cmpd="sng" algn="ctr">
+                      <a:solidFill>
+                        <a:srgbClr val="DADCE0"/>
+                      </a:solidFill>
+                      <a:prstDash val="solid"/>
+                      <a:round/>
+                      <a:headEnd type="none" w="med" len="med"/>
+                      <a:tailEnd type="none" w="med" len="med"/>
+                    </a:lnT>
+                    <a:lnB w="12700" cap="flat" cmpd="sng" algn="ctr">
+                      <a:solidFill>
+                        <a:srgbClr val="DADCE0"/>
+                      </a:solidFill>
+                      <a:prstDash val="solid"/>
+                      <a:round/>
+                      <a:headEnd type="none" w="med" len="med"/>
+                      <a:tailEnd type="none" w="med" len="med"/>
+                    </a:lnB>
+                    <a:solidFill>
+                      <a:srgbClr val="FFFFFF"/>
+                    </a:solidFill>
+                  </a:tcPr>
+                </a:tc>
+                <a:tc>
+                  <a:txBody>
+                    <a:bodyPr/>
+                    <a:lstStyle/>
+                    <a:p>
+                      <a:pPr algn="l" indent="0" marL="0">
+                        <a:buNone/>
+                      </a:pPr>
+                      <a:r>
+                        <a:rPr lang="en-US" sz="1400" dirty="0">
+                          <a:solidFill>
+                            <a:srgbClr val="202124"/>
+                          </a:solidFill>
+                        </a:rPr>
+                        <a:t>15 Questions</a:t>
+                      </a:r>
+                      <a:endParaRPr lang="en-US" sz="1400" dirty="0"/>
+                    </a:p>
+                  </a:txBody>
+                  <a:tcPr marL="91440" marR="91440" marT="45720" marB="45720" anchor="ctr">
+                    <a:lnL w="12700" cap="flat" cmpd="sng" algn="ctr">
+                      <a:solidFill>
+                        <a:srgbClr val="DADCE0"/>
+                      </a:solidFill>
+                      <a:prstDash val="solid"/>
+                      <a:round/>
+                      <a:headEnd type="none" w="med" len="med"/>
+                      <a:tailEnd type="none" w="med" len="med"/>
+                    </a:lnL>
+                    <a:lnR w="12700" cap="flat" cmpd="sng" algn="ctr">
+                      <a:solidFill>
+                        <a:srgbClr val="DADCE0"/>
+                      </a:solidFill>
+                      <a:prstDash val="solid"/>
+                      <a:round/>
+                      <a:headEnd type="none" w="med" len="med"/>
+                      <a:tailEnd type="none" w="med" len="med"/>
+                    </a:lnR>
+                    <a:lnT w="12700" cap="flat" cmpd="sng" algn="ctr">
+                      <a:solidFill>
+                        <a:srgbClr val="DADCE0"/>
+                      </a:solidFill>
+                      <a:prstDash val="solid"/>
+                      <a:round/>
+                      <a:headEnd type="none" w="med" len="med"/>
+                      <a:tailEnd type="none" w="med" len="med"/>
+                    </a:lnT>
+                    <a:lnB w="12700" cap="flat" cmpd="sng" algn="ctr">
+                      <a:solidFill>
+                        <a:srgbClr val="DADCE0"/>
+                      </a:solidFill>
+                      <a:prstDash val="solid"/>
+                      <a:round/>
+                      <a:headEnd type="none" w="med" len="med"/>
+                      <a:tailEnd type="none" w="med" len="med"/>
+                    </a:lnB>
+                    <a:solidFill>
+                      <a:srgbClr val="FFFFFF"/>
+                    </a:solidFill>
+                  </a:tcPr>
+                </a:tc>
+                <a:tc>
+                  <a:txBody>
+                    <a:bodyPr/>
+                    <a:lstStyle/>
+                    <a:p>
+                      <a:pPr algn="l" indent="0" marL="0">
+                        <a:buNone/>
+                      </a:pPr>
+                      <a:r>
+                        <a:rPr lang="en-US" sz="1400" dirty="0">
+                          <a:solidFill>
+                            <a:srgbClr val="202124"/>
+                          </a:solidFill>
+                        </a:rPr>
+                        <a:t>https://docs.google.com/spreadsheets/d/1IScTa4UfdjTZdB5UlyMu0AAd1g2LPlvGXwCgz1EAcow/edit?usp=sharing</a:t>
                       </a:r>
                       <a:endParaRPr lang="en-US" sz="1400" dirty="0"/>
                     </a:p>
@@ -15099,7 +16512,7 @@
                   <a:srgbClr val="1A73E8"/>
                 </a:solidFill>
               </a:rPr>
-              <a:t>3-Screen Interactive Solution Prototype Specification</a:t>
+              <a:t>3-Screen Interactive Solution Prototype Specification &amp; Live Links</a:t>
             </a:r>
             <a:endParaRPr lang="en-US" sz="1500" dirty="0"/>
           </a:p>
@@ -15393,7 +16806,7 @@
                             <a:srgbClr val="1A73E8"/>
                           </a:solidFill>
                         </a:rPr>
-                        <a:t>Rendered Output</a:t>
+                        <a:t>Rendered Output &amp; Live URL</a:t>
                       </a:r>
                       <a:endParaRPr lang="en-US" sz="1400" dirty="0"/>
                     </a:p>
@@ -16622,6 +18035,313 @@
                           </a:solidFill>
                         </a:rPr>
                         <a:t>Expands 4-5 surrounding photos</a:t>
+                      </a:r>
+                      <a:endParaRPr lang="en-US" sz="1400" dirty="0"/>
+                    </a:p>
+                  </a:txBody>
+                  <a:tcPr marL="91440" marR="91440" marT="45720" marB="45720" anchor="ctr">
+                    <a:lnL w="12700" cap="flat" cmpd="sng" algn="ctr">
+                      <a:solidFill>
+                        <a:srgbClr val="DADCE0"/>
+                      </a:solidFill>
+                      <a:prstDash val="solid"/>
+                      <a:round/>
+                      <a:headEnd type="none" w="med" len="med"/>
+                      <a:tailEnd type="none" w="med" len="med"/>
+                    </a:lnL>
+                    <a:lnR w="12700" cap="flat" cmpd="sng" algn="ctr">
+                      <a:solidFill>
+                        <a:srgbClr val="DADCE0"/>
+                      </a:solidFill>
+                      <a:prstDash val="solid"/>
+                      <a:round/>
+                      <a:headEnd type="none" w="med" len="med"/>
+                      <a:tailEnd type="none" w="med" len="med"/>
+                    </a:lnR>
+                    <a:lnT w="12700" cap="flat" cmpd="sng" algn="ctr">
+                      <a:solidFill>
+                        <a:srgbClr val="DADCE0"/>
+                      </a:solidFill>
+                      <a:prstDash val="solid"/>
+                      <a:round/>
+                      <a:headEnd type="none" w="med" len="med"/>
+                      <a:tailEnd type="none" w="med" len="med"/>
+                    </a:lnT>
+                    <a:lnB w="12700" cap="flat" cmpd="sng" algn="ctr">
+                      <a:solidFill>
+                        <a:srgbClr val="DADCE0"/>
+                      </a:solidFill>
+                      <a:prstDash val="solid"/>
+                      <a:round/>
+                      <a:headEnd type="none" w="med" len="med"/>
+                      <a:tailEnd type="none" w="med" len="med"/>
+                    </a:lnB>
+                    <a:solidFill>
+                      <a:srgbClr val="FFFFFF"/>
+                    </a:solidFill>
+                  </a:tcPr>
+                </a:tc>
+              </a:tr>
+              <a:tr h="0">
+                <a:tc>
+                  <a:txBody>
+                    <a:bodyPr/>
+                    <a:lstStyle/>
+                    <a:p>
+                      <a:pPr algn="l" indent="0" marL="0">
+                        <a:buNone/>
+                      </a:pPr>
+                      <a:r>
+                        <a:rPr lang="en-US" sz="1400" dirty="0">
+                          <a:solidFill>
+                            <a:srgbClr val="202124"/>
+                          </a:solidFill>
+                        </a:rPr>
+                        <a:t>Live App 2 MVP Link</a:t>
+                      </a:r>
+                      <a:endParaRPr lang="en-US" sz="1400" dirty="0"/>
+                    </a:p>
+                  </a:txBody>
+                  <a:tcPr marL="91440" marR="91440" marT="45720" marB="45720" anchor="ctr">
+                    <a:lnL w="12700" cap="flat" cmpd="sng" algn="ctr">
+                      <a:solidFill>
+                        <a:srgbClr val="DADCE0"/>
+                      </a:solidFill>
+                      <a:prstDash val="solid"/>
+                      <a:round/>
+                      <a:headEnd type="none" w="med" len="med"/>
+                      <a:tailEnd type="none" w="med" len="med"/>
+                    </a:lnL>
+                    <a:lnR w="12700" cap="flat" cmpd="sng" algn="ctr">
+                      <a:solidFill>
+                        <a:srgbClr val="DADCE0"/>
+                      </a:solidFill>
+                      <a:prstDash val="solid"/>
+                      <a:round/>
+                      <a:headEnd type="none" w="med" len="med"/>
+                      <a:tailEnd type="none" w="med" len="med"/>
+                    </a:lnR>
+                    <a:lnT w="12700" cap="flat" cmpd="sng" algn="ctr">
+                      <a:solidFill>
+                        <a:srgbClr val="DADCE0"/>
+                      </a:solidFill>
+                      <a:prstDash val="solid"/>
+                      <a:round/>
+                      <a:headEnd type="none" w="med" len="med"/>
+                      <a:tailEnd type="none" w="med" len="med"/>
+                    </a:lnT>
+                    <a:lnB w="12700" cap="flat" cmpd="sng" algn="ctr">
+                      <a:solidFill>
+                        <a:srgbClr val="DADCE0"/>
+                      </a:solidFill>
+                      <a:prstDash val="solid"/>
+                      <a:round/>
+                      <a:headEnd type="none" w="med" len="med"/>
+                      <a:tailEnd type="none" w="med" len="med"/>
+                    </a:lnB>
+                    <a:solidFill>
+                      <a:srgbClr val="FFFFFF"/>
+                    </a:solidFill>
+                  </a:tcPr>
+                </a:tc>
+                <a:tc>
+                  <a:txBody>
+                    <a:bodyPr/>
+                    <a:lstStyle/>
+                    <a:p>
+                      <a:pPr algn="l" indent="0" marL="0">
+                        <a:buNone/>
+                      </a:pPr>
+                      <a:r>
+                        <a:rPr lang="en-US" sz="1400" dirty="0">
+                          <a:solidFill>
+                            <a:srgbClr val="202124"/>
+                          </a:solidFill>
+                        </a:rPr>
+                        <a:t>Deployed Vercel MVP App</a:t>
+                      </a:r>
+                      <a:endParaRPr lang="en-US" sz="1400" dirty="0"/>
+                    </a:p>
+                  </a:txBody>
+                  <a:tcPr marL="91440" marR="91440" marT="45720" marB="45720" anchor="ctr">
+                    <a:lnL w="12700" cap="flat" cmpd="sng" algn="ctr">
+                      <a:solidFill>
+                        <a:srgbClr val="DADCE0"/>
+                      </a:solidFill>
+                      <a:prstDash val="solid"/>
+                      <a:round/>
+                      <a:headEnd type="none" w="med" len="med"/>
+                      <a:tailEnd type="none" w="med" len="med"/>
+                    </a:lnL>
+                    <a:lnR w="12700" cap="flat" cmpd="sng" algn="ctr">
+                      <a:solidFill>
+                        <a:srgbClr val="DADCE0"/>
+                      </a:solidFill>
+                      <a:prstDash val="solid"/>
+                      <a:round/>
+                      <a:headEnd type="none" w="med" len="med"/>
+                      <a:tailEnd type="none" w="med" len="med"/>
+                    </a:lnR>
+                    <a:lnT w="12700" cap="flat" cmpd="sng" algn="ctr">
+                      <a:solidFill>
+                        <a:srgbClr val="DADCE0"/>
+                      </a:solidFill>
+                      <a:prstDash val="solid"/>
+                      <a:round/>
+                      <a:headEnd type="none" w="med" len="med"/>
+                      <a:tailEnd type="none" w="med" len="med"/>
+                    </a:lnT>
+                    <a:lnB w="12700" cap="flat" cmpd="sng" algn="ctr">
+                      <a:solidFill>
+                        <a:srgbClr val="DADCE0"/>
+                      </a:solidFill>
+                      <a:prstDash val="solid"/>
+                      <a:round/>
+                      <a:headEnd type="none" w="med" len="med"/>
+                      <a:tailEnd type="none" w="med" len="med"/>
+                    </a:lnB>
+                    <a:solidFill>
+                      <a:srgbClr val="FFFFFF"/>
+                    </a:solidFill>
+                  </a:tcPr>
+                </a:tc>
+                <a:tc>
+                  <a:txBody>
+                    <a:bodyPr/>
+                    <a:lstStyle/>
+                    <a:p>
+                      <a:pPr algn="l" indent="0" marL="0">
+                        <a:buNone/>
+                      </a:pPr>
+                      <a:r>
+                        <a:rPr lang="en-US" sz="1400" dirty="0">
+                          <a:solidFill>
+                            <a:srgbClr val="202124"/>
+                          </a:solidFill>
+                        </a:rPr>
+                        <a:t>Interactive Prototype Testing</a:t>
+                      </a:r>
+                      <a:endParaRPr lang="en-US" sz="1400" dirty="0"/>
+                    </a:p>
+                  </a:txBody>
+                  <a:tcPr marL="91440" marR="91440" marT="45720" marB="45720" anchor="ctr">
+                    <a:lnL w="12700" cap="flat" cmpd="sng" algn="ctr">
+                      <a:solidFill>
+                        <a:srgbClr val="DADCE0"/>
+                      </a:solidFill>
+                      <a:prstDash val="solid"/>
+                      <a:round/>
+                      <a:headEnd type="none" w="med" len="med"/>
+                      <a:tailEnd type="none" w="med" len="med"/>
+                    </a:lnL>
+                    <a:lnR w="12700" cap="flat" cmpd="sng" algn="ctr">
+                      <a:solidFill>
+                        <a:srgbClr val="DADCE0"/>
+                      </a:solidFill>
+                      <a:prstDash val="solid"/>
+                      <a:round/>
+                      <a:headEnd type="none" w="med" len="med"/>
+                      <a:tailEnd type="none" w="med" len="med"/>
+                    </a:lnR>
+                    <a:lnT w="12700" cap="flat" cmpd="sng" algn="ctr">
+                      <a:solidFill>
+                        <a:srgbClr val="DADCE0"/>
+                      </a:solidFill>
+                      <a:prstDash val="solid"/>
+                      <a:round/>
+                      <a:headEnd type="none" w="med" len="med"/>
+                      <a:tailEnd type="none" w="med" len="med"/>
+                    </a:lnT>
+                    <a:lnB w="12700" cap="flat" cmpd="sng" algn="ctr">
+                      <a:solidFill>
+                        <a:srgbClr val="DADCE0"/>
+                      </a:solidFill>
+                      <a:prstDash val="solid"/>
+                      <a:round/>
+                      <a:headEnd type="none" w="med" len="med"/>
+                      <a:tailEnd type="none" w="med" len="med"/>
+                    </a:lnB>
+                    <a:solidFill>
+                      <a:srgbClr val="FFFFFF"/>
+                    </a:solidFill>
+                  </a:tcPr>
+                </a:tc>
+                <a:tc>
+                  <a:txBody>
+                    <a:bodyPr/>
+                    <a:lstStyle/>
+                    <a:p>
+                      <a:pPr algn="l" indent="0" marL="0">
+                        <a:buNone/>
+                      </a:pPr>
+                      <a:r>
+                        <a:rPr lang="en-US" sz="1400" dirty="0">
+                          <a:solidFill>
+                            <a:srgbClr val="202124"/>
+                          </a:solidFill>
+                        </a:rPr>
+                        <a:t>Live REST API Endpoints</a:t>
+                      </a:r>
+                      <a:endParaRPr lang="en-US" sz="1400" dirty="0"/>
+                    </a:p>
+                  </a:txBody>
+                  <a:tcPr marL="91440" marR="91440" marT="45720" marB="45720" anchor="ctr">
+                    <a:lnL w="12700" cap="flat" cmpd="sng" algn="ctr">
+                      <a:solidFill>
+                        <a:srgbClr val="DADCE0"/>
+                      </a:solidFill>
+                      <a:prstDash val="solid"/>
+                      <a:round/>
+                      <a:headEnd type="none" w="med" len="med"/>
+                      <a:tailEnd type="none" w="med" len="med"/>
+                    </a:lnL>
+                    <a:lnR w="12700" cap="flat" cmpd="sng" algn="ctr">
+                      <a:solidFill>
+                        <a:srgbClr val="DADCE0"/>
+                      </a:solidFill>
+                      <a:prstDash val="solid"/>
+                      <a:round/>
+                      <a:headEnd type="none" w="med" len="med"/>
+                      <a:tailEnd type="none" w="med" len="med"/>
+                    </a:lnR>
+                    <a:lnT w="12700" cap="flat" cmpd="sng" algn="ctr">
+                      <a:solidFill>
+                        <a:srgbClr val="DADCE0"/>
+                      </a:solidFill>
+                      <a:prstDash val="solid"/>
+                      <a:round/>
+                      <a:headEnd type="none" w="med" len="med"/>
+                      <a:tailEnd type="none" w="med" len="med"/>
+                    </a:lnT>
+                    <a:lnB w="12700" cap="flat" cmpd="sng" algn="ctr">
+                      <a:solidFill>
+                        <a:srgbClr val="DADCE0"/>
+                      </a:solidFill>
+                      <a:prstDash val="solid"/>
+                      <a:round/>
+                      <a:headEnd type="none" w="med" len="med"/>
+                      <a:tailEnd type="none" w="med" len="med"/>
+                    </a:lnB>
+                    <a:solidFill>
+                      <a:srgbClr val="FFFFFF"/>
+                    </a:solidFill>
+                  </a:tcPr>
+                </a:tc>
+                <a:tc>
+                  <a:txBody>
+                    <a:bodyPr/>
+                    <a:lstStyle/>
+                    <a:p>
+                      <a:pPr algn="l" indent="0" marL="0">
+                        <a:buNone/>
+                      </a:pPr>
+                      <a:r>
+                        <a:rPr lang="en-US" sz="1400" dirty="0">
+                          <a:solidFill>
+                            <a:srgbClr val="202124"/>
+                          </a:solidFill>
+                        </a:rPr>
+                        <a:t>https://google-photos-vague-memory-discover.vercel.app/</a:t>
                       </a:r>
                       <a:endParaRPr lang="en-US" sz="1400" dirty="0"/>
                     </a:p>
@@ -16868,7 +18588,7 @@
                   <a:srgbClr val="1A73E8"/>
                 </a:solidFill>
               </a:rPr>
-              <a:t>Ground-Truth Evaluation Benchmark &amp; API Audit Results</a:t>
+              <a:t>Ground-Truth Evaluation Benchmark &amp; API Audit Results (26 Photo Records)</a:t>
             </a:r>
             <a:endParaRPr lang="en-US" sz="1500" dirty="0"/>
           </a:p>

</xml_diff>

<commit_message>
Add 3 executive metric callout cards per slide above tables in presentation deck
</commit_message>
<xml_diff>
--- a/output/NL_GooglePhotos.pptx
+++ b/output/NL_GooglePhotos.pptx
@@ -1685,7 +1685,7 @@
         <p:spPr>
           <a:xfrm>
             <a:off x="0" y="0"/>
-            <a:ext cx="9144000" cy="1051560"/>
+            <a:ext cx="9144000" cy="960120"/>
           </a:xfrm>
           <a:prstGeom prst="rect">
             <a:avLst/>
@@ -1709,8 +1709,8 @@
         </p:nvSpPr>
         <p:spPr>
           <a:xfrm>
-            <a:off x="457200" y="109728"/>
-            <a:ext cx="8229600" cy="256032"/>
+            <a:off x="457200" y="91440"/>
+            <a:ext cx="8229600" cy="228600"/>
           </a:xfrm>
           <a:prstGeom prst="rect">
             <a:avLst/>
@@ -1745,8 +1745,8 @@
         </p:nvSpPr>
         <p:spPr>
           <a:xfrm>
-            <a:off x="457200" y="384048"/>
-            <a:ext cx="8229600" cy="594360"/>
+            <a:off x="457200" y="329184"/>
+            <a:ext cx="8229600" cy="548640"/>
           </a:xfrm>
           <a:prstGeom prst="rect">
             <a:avLst/>
@@ -1762,14 +1762,14 @@
               <a:buNone/>
             </a:pPr>
             <a:r>
-              <a:rPr lang="en-US" sz="2000" b="1" dirty="0">
+              <a:rPr lang="en-US" sz="1900" b="1" dirty="0">
                 <a:solidFill>
                   <a:srgbClr val="202124"/>
                 </a:solidFill>
               </a:rPr>
               <a:t>Gemini AI Memory Engine Solves Vague Retrieval via 1-Tap Timeline Context Jump</a:t>
             </a:r>
-            <a:endParaRPr lang="en-US" sz="2000" dirty="0"/>
+            <a:endParaRPr lang="en-US" sz="1900" dirty="0"/>
           </a:p>
         </p:txBody>
       </p:sp>
@@ -1781,8 +1781,8 @@
         </p:nvSpPr>
         <p:spPr>
           <a:xfrm>
-            <a:off x="457200" y="1143000"/>
-            <a:ext cx="8229600" cy="320040"/>
+            <a:off x="457200" y="1645920"/>
+            <a:ext cx="8229600" cy="274320"/>
           </a:xfrm>
           <a:prstGeom prst="rect">
             <a:avLst/>
@@ -1798,14 +1798,14 @@
               <a:buNone/>
             </a:pPr>
             <a:r>
-              <a:rPr lang="en-US" sz="1500" b="1" dirty="0">
+              <a:rPr lang="en-US" sz="1400" b="1" dirty="0">
                 <a:solidFill>
                   <a:srgbClr val="1A73E8"/>
                 </a:solidFill>
               </a:rPr>
               <a:t>Executive System Architecture, Empirical Metrics (N=1,000 / N=34) &amp; Live Deployments</a:t>
             </a:r>
-            <a:endParaRPr lang="en-US" sz="1500" dirty="0"/>
+            <a:endParaRPr lang="en-US" sz="1400" dirty="0"/>
           </a:p>
         </p:txBody>
       </p:sp>
@@ -1824,7 +1824,7 @@
           </p:nvPr>
         </p:nvGraphicFramePr>
         <p:xfrm>
-          <a:off x="457200" y="1508760"/>
+          <a:off x="457200" y="1938528"/>
           <a:ext cx="8229600" cy="914400"/>
         </p:xfrm>
         <a:graphic>
@@ -3692,8 +3692,8 @@
         </p:nvSpPr>
         <p:spPr>
           <a:xfrm>
-            <a:off x="457200" y="4937760"/>
-            <a:ext cx="8229600" cy="228600"/>
+            <a:off x="457200" y="4919472"/>
+            <a:ext cx="8229600" cy="201168"/>
           </a:xfrm>
           <a:prstGeom prst="rect">
             <a:avLst/>
@@ -3761,7 +3761,7 @@
         <p:spPr>
           <a:xfrm>
             <a:off x="0" y="0"/>
-            <a:ext cx="9144000" cy="1051560"/>
+            <a:ext cx="9144000" cy="960120"/>
           </a:xfrm>
           <a:prstGeom prst="rect">
             <a:avLst/>
@@ -3785,8 +3785,8 @@
         </p:nvSpPr>
         <p:spPr>
           <a:xfrm>
-            <a:off x="457200" y="109728"/>
-            <a:ext cx="8229600" cy="256032"/>
+            <a:off x="457200" y="91440"/>
+            <a:ext cx="8229600" cy="228600"/>
           </a:xfrm>
           <a:prstGeom prst="rect">
             <a:avLst/>
@@ -3821,8 +3821,8 @@
         </p:nvSpPr>
         <p:spPr>
           <a:xfrm>
-            <a:off x="457200" y="384048"/>
-            <a:ext cx="8229600" cy="594360"/>
+            <a:off x="457200" y="329184"/>
+            <a:ext cx="8229600" cy="548640"/>
           </a:xfrm>
           <a:prstGeom prst="rect">
             <a:avLst/>
@@ -3838,14 +3838,14 @@
               <a:buNone/>
             </a:pPr>
             <a:r>
-              <a:rPr lang="en-US" sz="2000" b="1" dirty="0">
+              <a:rPr lang="en-US" sz="1900" b="1" dirty="0">
                 <a:solidFill>
                   <a:srgbClr val="202124"/>
                 </a:solidFill>
               </a:rPr>
               <a:t>Phased 1% to 100% Rollout Guarded by Spatial Filters, Privacy &amp; Remote Kill-Switches</a:t>
             </a:r>
-            <a:endParaRPr lang="en-US" sz="2000" dirty="0"/>
+            <a:endParaRPr lang="en-US" sz="1900" dirty="0"/>
           </a:p>
         </p:txBody>
       </p:sp>
@@ -3857,8 +3857,8 @@
         </p:nvSpPr>
         <p:spPr>
           <a:xfrm>
-            <a:off x="457200" y="1143000"/>
-            <a:ext cx="8229600" cy="320040"/>
+            <a:off x="457200" y="1645920"/>
+            <a:ext cx="8229600" cy="274320"/>
           </a:xfrm>
           <a:prstGeom prst="rect">
             <a:avLst/>
@@ -3874,14 +3874,14 @@
               <a:buNone/>
             </a:pPr>
             <a:r>
-              <a:rPr lang="en-US" sz="1500" b="1" dirty="0">
+              <a:rPr lang="en-US" sz="1400" b="1" dirty="0">
                 <a:solidFill>
                   <a:srgbClr val="1A73E8"/>
                 </a:solidFill>
               </a:rPr>
               <a:t>Production Risk Mitigation, On-Device Governance &amp; 4-Phase Experimentation Ramp</a:t>
             </a:r>
-            <a:endParaRPr lang="en-US" sz="1500" dirty="0"/>
+            <a:endParaRPr lang="en-US" sz="1400" dirty="0"/>
           </a:p>
         </p:txBody>
       </p:sp>
@@ -3900,7 +3900,7 @@
           </p:nvPr>
         </p:nvGraphicFramePr>
         <p:xfrm>
-          <a:off x="457200" y="1508760"/>
+          <a:off x="457200" y="1938528"/>
           <a:ext cx="8229600" cy="914400"/>
         </p:xfrm>
         <a:graphic>
@@ -5768,8 +5768,8 @@
         </p:nvSpPr>
         <p:spPr>
           <a:xfrm>
-            <a:off x="457200" y="4937760"/>
-            <a:ext cx="8229600" cy="228600"/>
+            <a:off x="457200" y="4919472"/>
+            <a:ext cx="8229600" cy="201168"/>
           </a:xfrm>
           <a:prstGeom prst="rect">
             <a:avLst/>
@@ -5837,7 +5837,7 @@
         <p:spPr>
           <a:xfrm>
             <a:off x="0" y="0"/>
-            <a:ext cx="9144000" cy="1051560"/>
+            <a:ext cx="9144000" cy="960120"/>
           </a:xfrm>
           <a:prstGeom prst="rect">
             <a:avLst/>
@@ -5861,8 +5861,8 @@
         </p:nvSpPr>
         <p:spPr>
           <a:xfrm>
-            <a:off x="457200" y="109728"/>
-            <a:ext cx="8229600" cy="256032"/>
+            <a:off x="457200" y="91440"/>
+            <a:ext cx="8229600" cy="228600"/>
           </a:xfrm>
           <a:prstGeom prst="rect">
             <a:avLst/>
@@ -5897,8 +5897,8 @@
         </p:nvSpPr>
         <p:spPr>
           <a:xfrm>
-            <a:off x="457200" y="384048"/>
-            <a:ext cx="8229600" cy="594360"/>
+            <a:off x="457200" y="329184"/>
+            <a:ext cx="8229600" cy="548640"/>
           </a:xfrm>
           <a:prstGeom prst="rect">
             <a:avLst/>
@@ -5914,14 +5914,14 @@
               <a:buNone/>
             </a:pPr>
             <a:r>
-              <a:rPr lang="en-US" sz="2000" b="1" dirty="0">
+              <a:rPr lang="en-US" sz="1900" b="1" dirty="0">
                 <a:solidFill>
                   <a:srgbClr val="202124"/>
                 </a:solidFill>
               </a:rPr>
               <a:t>Decomposing Vague Retrieval Failure into Metric Tree &amp; ARR Retention Impact</a:t>
             </a:r>
-            <a:endParaRPr lang="en-US" sz="2000" dirty="0"/>
+            <a:endParaRPr lang="en-US" sz="1900" dirty="0"/>
           </a:p>
         </p:txBody>
       </p:sp>
@@ -5933,8 +5933,8 @@
         </p:nvSpPr>
         <p:spPr>
           <a:xfrm>
-            <a:off x="457200" y="1143000"/>
-            <a:ext cx="8229600" cy="320040"/>
+            <a:off x="457200" y="1645920"/>
+            <a:ext cx="8229600" cy="274320"/>
           </a:xfrm>
           <a:prstGeom prst="rect">
             <a:avLst/>
@@ -5950,14 +5950,14 @@
               <a:buNone/>
             </a:pPr>
             <a:r>
-              <a:rPr lang="en-US" sz="1500" b="1" dirty="0">
+              <a:rPr lang="en-US" sz="1400" b="1" dirty="0">
                 <a:solidFill>
                   <a:srgbClr val="1A73E8"/>
                 </a:solidFill>
               </a:rPr>
               <a:t>Canonical North-Star Metric Decomposition Tree &amp; Strategic Financial Lifts</a:t>
             </a:r>
-            <a:endParaRPr lang="en-US" sz="1500" dirty="0"/>
+            <a:endParaRPr lang="en-US" sz="1400" dirty="0"/>
           </a:p>
         </p:txBody>
       </p:sp>
@@ -5976,7 +5976,7 @@
           </p:nvPr>
         </p:nvGraphicFramePr>
         <p:xfrm>
-          <a:off x="457200" y="1508760"/>
+          <a:off x="457200" y="1938528"/>
           <a:ext cx="8229600" cy="914400"/>
         </p:xfrm>
         <a:graphic>
@@ -7844,8 +7844,8 @@
         </p:nvSpPr>
         <p:spPr>
           <a:xfrm>
-            <a:off x="457200" y="4937760"/>
-            <a:ext cx="8229600" cy="228600"/>
+            <a:off x="457200" y="4919472"/>
+            <a:ext cx="8229600" cy="201168"/>
           </a:xfrm>
           <a:prstGeom prst="rect">
             <a:avLst/>
@@ -7913,7 +7913,7 @@
         <p:spPr>
           <a:xfrm>
             <a:off x="0" y="0"/>
-            <a:ext cx="9144000" cy="1051560"/>
+            <a:ext cx="9144000" cy="960120"/>
           </a:xfrm>
           <a:prstGeom prst="rect">
             <a:avLst/>
@@ -7937,8 +7937,8 @@
         </p:nvSpPr>
         <p:spPr>
           <a:xfrm>
-            <a:off x="457200" y="109728"/>
-            <a:ext cx="8229600" cy="256032"/>
+            <a:off x="457200" y="91440"/>
+            <a:ext cx="8229600" cy="228600"/>
           </a:xfrm>
           <a:prstGeom prst="rect">
             <a:avLst/>
@@ -7973,8 +7973,8 @@
         </p:nvSpPr>
         <p:spPr>
           <a:xfrm>
-            <a:off x="457200" y="384048"/>
-            <a:ext cx="8229600" cy="594360"/>
+            <a:off x="457200" y="329184"/>
+            <a:ext cx="8229600" cy="548640"/>
           </a:xfrm>
           <a:prstGeom prst="rect">
             <a:avLst/>
@@ -7990,14 +7990,14 @@
               <a:buNone/>
             </a:pPr>
             <a:r>
-              <a:rPr lang="en-US" sz="2000" b="1" dirty="0">
+              <a:rPr lang="en-US" sz="1900" b="1" dirty="0">
                 <a:solidFill>
                   <a:srgbClr val="202124"/>
                 </a:solidFill>
               </a:rPr>
               <a:t>1,000 Public Reviews Reveal 67.6% Query Surfacing Failure and 50.0% Document Need</a:t>
             </a:r>
-            <a:endParaRPr lang="en-US" sz="2000" dirty="0"/>
+            <a:endParaRPr lang="en-US" sz="1900" dirty="0"/>
           </a:p>
         </p:txBody>
       </p:sp>
@@ -8009,8 +8009,8 @@
         </p:nvSpPr>
         <p:spPr>
           <a:xfrm>
-            <a:off x="457200" y="1143000"/>
-            <a:ext cx="8229600" cy="320040"/>
+            <a:off x="457200" y="1645920"/>
+            <a:ext cx="8229600" cy="274320"/>
           </a:xfrm>
           <a:prstGeom prst="rect">
             <a:avLst/>
@@ -8026,14 +8026,14 @@
               <a:buNone/>
             </a:pPr>
             <a:r>
-              <a:rPr lang="en-US" sz="1500" b="1" dirty="0">
+              <a:rPr lang="en-US" sz="1400" b="1" dirty="0">
                 <a:solidFill>
                   <a:srgbClr val="1A73E8"/>
                 </a:solidFill>
               </a:rPr>
               <a:t>Multi-Platform Public Feedback Analytics (Reddit/Play Store/Community) via Gemini 2.5 Flash</a:t>
             </a:r>
-            <a:endParaRPr lang="en-US" sz="1500" dirty="0"/>
+            <a:endParaRPr lang="en-US" sz="1400" dirty="0"/>
           </a:p>
         </p:txBody>
       </p:sp>
@@ -8052,7 +8052,7 @@
           </p:nvPr>
         </p:nvGraphicFramePr>
         <p:xfrm>
-          <a:off x="457200" y="1508760"/>
+          <a:off x="457200" y="1938528"/>
           <a:ext cx="8229600" cy="914400"/>
         </p:xfrm>
         <a:graphic>
@@ -9920,8 +9920,8 @@
         </p:nvSpPr>
         <p:spPr>
           <a:xfrm>
-            <a:off x="457200" y="4937760"/>
-            <a:ext cx="8229600" cy="228600"/>
+            <a:off x="457200" y="4919472"/>
+            <a:ext cx="8229600" cy="201168"/>
           </a:xfrm>
           <a:prstGeom prst="rect">
             <a:avLst/>
@@ -9989,7 +9989,7 @@
         <p:spPr>
           <a:xfrm>
             <a:off x="0" y="0"/>
-            <a:ext cx="9144000" cy="1051560"/>
+            <a:ext cx="9144000" cy="960120"/>
           </a:xfrm>
           <a:prstGeom prst="rect">
             <a:avLst/>
@@ -10013,8 +10013,8 @@
         </p:nvSpPr>
         <p:spPr>
           <a:xfrm>
-            <a:off x="457200" y="109728"/>
-            <a:ext cx="8229600" cy="256032"/>
+            <a:off x="457200" y="91440"/>
+            <a:ext cx="8229600" cy="228600"/>
           </a:xfrm>
           <a:prstGeom prst="rect">
             <a:avLst/>
@@ -10049,8 +10049,8 @@
         </p:nvSpPr>
         <p:spPr>
           <a:xfrm>
-            <a:off x="457200" y="384048"/>
-            <a:ext cx="8229600" cy="594360"/>
+            <a:off x="457200" y="329184"/>
+            <a:ext cx="8229600" cy="548640"/>
           </a:xfrm>
           <a:prstGeom prst="rect">
             <a:avLst/>
@@ -10066,14 +10066,14 @@
               <a:buNone/>
             </a:pPr>
             <a:r>
-              <a:rPr lang="en-US" sz="2000" b="1" dirty="0">
+              <a:rPr lang="en-US" sz="1900" b="1" dirty="0">
                 <a:solidFill>
                   <a:srgbClr val="202124"/>
                 </a:solidFill>
               </a:rPr>
               <a:t>Primary Research (N=34) Discovers 76.5% Scroll Fatigue Cliff and 73.5% Anchor Recall</a:t>
             </a:r>
-            <a:endParaRPr lang="en-US" sz="2000" dirty="0"/>
+            <a:endParaRPr lang="en-US" sz="1900" dirty="0"/>
           </a:p>
         </p:txBody>
       </p:sp>
@@ -10085,8 +10085,8 @@
         </p:nvSpPr>
         <p:spPr>
           <a:xfrm>
-            <a:off x="457200" y="1143000"/>
-            <a:ext cx="8229600" cy="320040"/>
+            <a:off x="457200" y="1645920"/>
+            <a:ext cx="8229600" cy="274320"/>
           </a:xfrm>
           <a:prstGeom prst="rect">
             <a:avLst/>
@@ -10102,14 +10102,14 @@
               <a:buNone/>
             </a:pPr>
             <a:r>
-              <a:rPr lang="en-US" sz="1500" b="1" dirty="0">
+              <a:rPr lang="en-US" sz="1400" b="1" dirty="0">
                 <a:solidFill>
                   <a:srgbClr val="1A73E8"/>
                 </a:solidFill>
               </a:rPr>
               <a:t>Quantitative Primary Research Survey &amp; Task Breakdown (15-Question Protocol)</a:t>
             </a:r>
-            <a:endParaRPr lang="en-US" sz="1500" dirty="0"/>
+            <a:endParaRPr lang="en-US" sz="1400" dirty="0"/>
           </a:p>
         </p:txBody>
       </p:sp>
@@ -10128,7 +10128,7 @@
           </p:nvPr>
         </p:nvGraphicFramePr>
         <p:xfrm>
-          <a:off x="457200" y="1508760"/>
+          <a:off x="457200" y="1938528"/>
           <a:ext cx="8229600" cy="914400"/>
         </p:xfrm>
         <a:graphic>
@@ -11629,8 +11629,8 @@
         </p:nvSpPr>
         <p:spPr>
           <a:xfrm>
-            <a:off x="457200" y="4937760"/>
-            <a:ext cx="8229600" cy="228600"/>
+            <a:off x="457200" y="4919472"/>
+            <a:ext cx="8229600" cy="201168"/>
           </a:xfrm>
           <a:prstGeom prst="rect">
             <a:avLst/>
@@ -11698,7 +11698,7 @@
         <p:spPr>
           <a:xfrm>
             <a:off x="0" y="0"/>
-            <a:ext cx="9144000" cy="1051560"/>
+            <a:ext cx="9144000" cy="960120"/>
           </a:xfrm>
           <a:prstGeom prst="rect">
             <a:avLst/>
@@ -11722,8 +11722,8 @@
         </p:nvSpPr>
         <p:spPr>
           <a:xfrm>
-            <a:off x="457200" y="109728"/>
-            <a:ext cx="8229600" cy="256032"/>
+            <a:off x="457200" y="91440"/>
+            <a:ext cx="8229600" cy="228600"/>
           </a:xfrm>
           <a:prstGeom prst="rect">
             <a:avLst/>
@@ -11758,8 +11758,8 @@
         </p:nvSpPr>
         <p:spPr>
           <a:xfrm>
-            <a:off x="457200" y="384048"/>
-            <a:ext cx="8229600" cy="594360"/>
+            <a:off x="457200" y="329184"/>
+            <a:ext cx="8229600" cy="548640"/>
           </a:xfrm>
           <a:prstGeom prst="rect">
             <a:avLst/>
@@ -11775,14 +11775,14 @@
               <a:buNone/>
             </a:pPr>
             <a:r>
-              <a:rPr lang="en-US" sz="2000" b="1" dirty="0">
+              <a:rPr lang="en-US" sz="1900" b="1" dirty="0">
                 <a:solidFill>
                   <a:srgbClr val="202124"/>
                 </a:solidFill>
               </a:rPr>
               <a:t>Targeting High-Volume Archivers (5,000+ Items) Facing Critical Document Retrieval Failure</a:t>
             </a:r>
-            <a:endParaRPr lang="en-US" sz="2000" dirty="0"/>
+            <a:endParaRPr lang="en-US" sz="1900" dirty="0"/>
           </a:p>
         </p:txBody>
       </p:sp>
@@ -11794,8 +11794,8 @@
         </p:nvSpPr>
         <p:spPr>
           <a:xfrm>
-            <a:off x="457200" y="1143000"/>
-            <a:ext cx="8229600" cy="320040"/>
+            <a:off x="457200" y="1645920"/>
+            <a:ext cx="8229600" cy="274320"/>
           </a:xfrm>
           <a:prstGeom prst="rect">
             <a:avLst/>
@@ -11811,14 +11811,14 @@
               <a:buNone/>
             </a:pPr>
             <a:r>
-              <a:rPr lang="en-US" sz="1500" b="1" dirty="0">
+              <a:rPr lang="en-US" sz="1400" b="1" dirty="0">
                 <a:solidFill>
                   <a:srgbClr val="1A73E8"/>
                 </a:solidFill>
               </a:rPr>
               <a:t>Behavioral Persona Segmentation Matrix &amp; High-Value Friction Quantification</a:t>
             </a:r>
-            <a:endParaRPr lang="en-US" sz="1500" dirty="0"/>
+            <a:endParaRPr lang="en-US" sz="1400" dirty="0"/>
           </a:p>
         </p:txBody>
       </p:sp>
@@ -11837,7 +11837,7 @@
           </p:nvPr>
         </p:nvGraphicFramePr>
         <p:xfrm>
-          <a:off x="457200" y="1508760"/>
+          <a:off x="457200" y="1938528"/>
           <a:ext cx="8229600" cy="914400"/>
         </p:xfrm>
         <a:graphic>
@@ -13338,8 +13338,8 @@
         </p:nvSpPr>
         <p:spPr>
           <a:xfrm>
-            <a:off x="457200" y="4937760"/>
-            <a:ext cx="8229600" cy="228600"/>
+            <a:off x="457200" y="4919472"/>
+            <a:ext cx="8229600" cy="201168"/>
           </a:xfrm>
           <a:prstGeom prst="rect">
             <a:avLst/>
@@ -13407,7 +13407,7 @@
         <p:spPr>
           <a:xfrm>
             <a:off x="0" y="0"/>
-            <a:ext cx="9144000" cy="1051560"/>
+            <a:ext cx="9144000" cy="960120"/>
           </a:xfrm>
           <a:prstGeom prst="rect">
             <a:avLst/>
@@ -13431,8 +13431,8 @@
         </p:nvSpPr>
         <p:spPr>
           <a:xfrm>
-            <a:off x="457200" y="109728"/>
-            <a:ext cx="8229600" cy="256032"/>
+            <a:off x="457200" y="91440"/>
+            <a:ext cx="8229600" cy="228600"/>
           </a:xfrm>
           <a:prstGeom prst="rect">
             <a:avLst/>
@@ -13467,8 +13467,8 @@
         </p:nvSpPr>
         <p:spPr>
           <a:xfrm>
-            <a:off x="457200" y="384048"/>
-            <a:ext cx="8229600" cy="594360"/>
+            <a:off x="457200" y="329184"/>
+            <a:ext cx="8229600" cy="548640"/>
           </a:xfrm>
           <a:prstGeom prst="rect">
             <a:avLst/>
@@ -13484,14 +13484,14 @@
               <a:buNone/>
             </a:pPr>
             <a:r>
-              <a:rPr lang="en-US" sz="2000" b="1" dirty="0">
+              <a:rPr lang="en-US" sz="1900" b="1" dirty="0">
                 <a:solidFill>
                   <a:srgbClr val="202124"/>
                 </a:solidFill>
               </a:rPr>
               <a:t>Core Root Cause: Memory Recalls Visual Anchors While Search Requires Exact Tags</a:t>
             </a:r>
-            <a:endParaRPr lang="en-US" sz="2000" dirty="0"/>
+            <a:endParaRPr lang="en-US" sz="1900" dirty="0"/>
           </a:p>
         </p:txBody>
       </p:sp>
@@ -13503,8 +13503,8 @@
         </p:nvSpPr>
         <p:spPr>
           <a:xfrm>
-            <a:off x="457200" y="1143000"/>
-            <a:ext cx="8229600" cy="320040"/>
+            <a:off x="457200" y="1645920"/>
+            <a:ext cx="8229600" cy="274320"/>
           </a:xfrm>
           <a:prstGeom prst="rect">
             <a:avLst/>
@@ -13520,14 +13520,14 @@
               <a:buNone/>
             </a:pPr>
             <a:r>
-              <a:rPr lang="en-US" sz="1500" b="1" dirty="0">
+              <a:rPr lang="en-US" sz="1400" b="1" dirty="0">
                 <a:solidFill>
                   <a:srgbClr val="1A73E8"/>
                 </a:solidFill>
               </a:rPr>
               <a:t>CFM-01 to CFM-04 Structural Failure Taxonomy &amp; Ground-Truth Isolation</a:t>
             </a:r>
-            <a:endParaRPr lang="en-US" sz="1500" dirty="0"/>
+            <a:endParaRPr lang="en-US" sz="1400" dirty="0"/>
           </a:p>
         </p:txBody>
       </p:sp>
@@ -13546,7 +13546,7 @@
           </p:nvPr>
         </p:nvGraphicFramePr>
         <p:xfrm>
-          <a:off x="457200" y="1508760"/>
+          <a:off x="457200" y="1938528"/>
           <a:ext cx="8229600" cy="914400"/>
         </p:xfrm>
         <a:graphic>
@@ -15107,8 +15107,8 @@
         </p:nvSpPr>
         <p:spPr>
           <a:xfrm>
-            <a:off x="457200" y="4937760"/>
-            <a:ext cx="8229600" cy="228600"/>
+            <a:off x="457200" y="4919472"/>
+            <a:ext cx="8229600" cy="201168"/>
           </a:xfrm>
           <a:prstGeom prst="rect">
             <a:avLst/>
@@ -15176,7 +15176,7 @@
         <p:spPr>
           <a:xfrm>
             <a:off x="0" y="0"/>
-            <a:ext cx="9144000" cy="1051560"/>
+            <a:ext cx="9144000" cy="960120"/>
           </a:xfrm>
           <a:prstGeom prst="rect">
             <a:avLst/>
@@ -15200,8 +15200,8 @@
         </p:nvSpPr>
         <p:spPr>
           <a:xfrm>
-            <a:off x="457200" y="109728"/>
-            <a:ext cx="8229600" cy="256032"/>
+            <a:off x="457200" y="91440"/>
+            <a:ext cx="8229600" cy="228600"/>
           </a:xfrm>
           <a:prstGeom prst="rect">
             <a:avLst/>
@@ -15236,8 +15236,8 @@
         </p:nvSpPr>
         <p:spPr>
           <a:xfrm>
-            <a:off x="457200" y="384048"/>
-            <a:ext cx="8229600" cy="594360"/>
+            <a:off x="457200" y="329184"/>
+            <a:ext cx="8229600" cy="548640"/>
           </a:xfrm>
           <a:prstGeom prst="rect">
             <a:avLst/>
@@ -15253,14 +15253,14 @@
               <a:buNone/>
             </a:pPr>
             <a:r>
-              <a:rPr lang="en-US" sz="2000" b="1" dirty="0">
+              <a:rPr lang="en-US" sz="1900" b="1" dirty="0">
                 <a:solidFill>
                   <a:srgbClr val="202124"/>
                 </a:solidFill>
               </a:rPr>
               <a:t>Concept A Outperforms Alternatives with 8.93/10 Score via 1-Tap Contextual Jump</a:t>
             </a:r>
-            <a:endParaRPr lang="en-US" sz="2000" dirty="0"/>
+            <a:endParaRPr lang="en-US" sz="1900" dirty="0"/>
           </a:p>
         </p:txBody>
       </p:sp>
@@ -15272,8 +15272,8 @@
         </p:nvSpPr>
         <p:spPr>
           <a:xfrm>
-            <a:off x="457200" y="1143000"/>
-            <a:ext cx="8229600" cy="320040"/>
+            <a:off x="457200" y="1645920"/>
+            <a:ext cx="8229600" cy="274320"/>
           </a:xfrm>
           <a:prstGeom prst="rect">
             <a:avLst/>
@@ -15289,14 +15289,14 @@
               <a:buNone/>
             </a:pPr>
             <a:r>
-              <a:rPr lang="en-US" sz="1500" b="1" dirty="0">
+              <a:rPr lang="en-US" sz="1400" b="1" dirty="0">
                 <a:solidFill>
                   <a:srgbClr val="1A73E8"/>
                 </a:solidFill>
               </a:rPr>
               <a:t>Architectural Trade-off Evaluation Matrix &amp; Quantitative Selection Rationale</a:t>
             </a:r>
-            <a:endParaRPr lang="en-US" sz="1500" dirty="0"/>
+            <a:endParaRPr lang="en-US" sz="1400" dirty="0"/>
           </a:p>
         </p:txBody>
       </p:sp>
@@ -15315,7 +15315,7 @@
           </p:nvPr>
         </p:nvGraphicFramePr>
         <p:xfrm>
-          <a:off x="457200" y="1508760"/>
+          <a:off x="457200" y="1938528"/>
           <a:ext cx="8229600" cy="914400"/>
         </p:xfrm>
         <a:graphic>
@@ -17059,8 +17059,8 @@
         </p:nvSpPr>
         <p:spPr>
           <a:xfrm>
-            <a:off x="457200" y="4937760"/>
-            <a:ext cx="8229600" cy="228600"/>
+            <a:off x="457200" y="4919472"/>
+            <a:ext cx="8229600" cy="201168"/>
           </a:xfrm>
           <a:prstGeom prst="rect">
             <a:avLst/>
@@ -17128,7 +17128,7 @@
         <p:spPr>
           <a:xfrm>
             <a:off x="0" y="0"/>
-            <a:ext cx="9144000" cy="1051560"/>
+            <a:ext cx="9144000" cy="960120"/>
           </a:xfrm>
           <a:prstGeom prst="rect">
             <a:avLst/>
@@ -17152,8 +17152,8 @@
         </p:nvSpPr>
         <p:spPr>
           <a:xfrm>
-            <a:off x="457200" y="109728"/>
-            <a:ext cx="8229600" cy="256032"/>
+            <a:off x="457200" y="91440"/>
+            <a:ext cx="8229600" cy="228600"/>
           </a:xfrm>
           <a:prstGeom prst="rect">
             <a:avLst/>
@@ -17188,8 +17188,8 @@
         </p:nvSpPr>
         <p:spPr>
           <a:xfrm>
-            <a:off x="457200" y="384048"/>
-            <a:ext cx="8229600" cy="594360"/>
+            <a:off x="457200" y="329184"/>
+            <a:ext cx="8229600" cy="548640"/>
           </a:xfrm>
           <a:prstGeom prst="rect">
             <a:avLst/>
@@ -17205,14 +17205,14 @@
               <a:buNone/>
             </a:pPr>
             <a:r>
-              <a:rPr lang="en-US" sz="2000" b="1" dirty="0">
+              <a:rPr lang="en-US" sz="1900" b="1" dirty="0">
                 <a:solidFill>
                   <a:srgbClr val="202124"/>
                 </a:solidFill>
               </a:rPr>
               <a:t>Interactive Gemini AI MVP Surfacing Candidate Anchors and 1-Tap Context Expansion</a:t>
             </a:r>
-            <a:endParaRPr lang="en-US" sz="2000" dirty="0"/>
+            <a:endParaRPr lang="en-US" sz="1900" dirty="0"/>
           </a:p>
         </p:txBody>
       </p:sp>
@@ -17224,8 +17224,8 @@
         </p:nvSpPr>
         <p:spPr>
           <a:xfrm>
-            <a:off x="457200" y="1143000"/>
-            <a:ext cx="8229600" cy="320040"/>
+            <a:off x="457200" y="1645920"/>
+            <a:ext cx="8229600" cy="274320"/>
           </a:xfrm>
           <a:prstGeom prst="rect">
             <a:avLst/>
@@ -17241,14 +17241,14 @@
               <a:buNone/>
             </a:pPr>
             <a:r>
-              <a:rPr lang="en-US" sz="1500" b="1" dirty="0">
+              <a:rPr lang="en-US" sz="1400" b="1" dirty="0">
                 <a:solidFill>
                   <a:srgbClr val="1A73E8"/>
                 </a:solidFill>
               </a:rPr>
               <a:t>3-Screen Interactive Solution Architecture Specification &amp; Live Links</a:t>
             </a:r>
-            <a:endParaRPr lang="en-US" sz="1500" dirty="0"/>
+            <a:endParaRPr lang="en-US" sz="1400" dirty="0"/>
           </a:p>
         </p:txBody>
       </p:sp>
@@ -17267,7 +17267,7 @@
           </p:nvPr>
         </p:nvGraphicFramePr>
         <p:xfrm>
-          <a:off x="457200" y="1508760"/>
+          <a:off x="457200" y="1938528"/>
           <a:ext cx="8229600" cy="914400"/>
         </p:xfrm>
         <a:graphic>
@@ -19135,8 +19135,8 @@
         </p:nvSpPr>
         <p:spPr>
           <a:xfrm>
-            <a:off x="457200" y="4937760"/>
-            <a:ext cx="8229600" cy="228600"/>
+            <a:off x="457200" y="4919472"/>
+            <a:ext cx="8229600" cy="201168"/>
           </a:xfrm>
           <a:prstGeom prst="rect">
             <a:avLst/>
@@ -19204,7 +19204,7 @@
         <p:spPr>
           <a:xfrm>
             <a:off x="0" y="0"/>
-            <a:ext cx="9144000" cy="1051560"/>
+            <a:ext cx="9144000" cy="960120"/>
           </a:xfrm>
           <a:prstGeom prst="rect">
             <a:avLst/>
@@ -19228,8 +19228,8 @@
         </p:nvSpPr>
         <p:spPr>
           <a:xfrm>
-            <a:off x="457200" y="109728"/>
-            <a:ext cx="8229600" cy="256032"/>
+            <a:off x="457200" y="91440"/>
+            <a:ext cx="8229600" cy="228600"/>
           </a:xfrm>
           <a:prstGeom prst="rect">
             <a:avLst/>
@@ -19264,8 +19264,8 @@
         </p:nvSpPr>
         <p:spPr>
           <a:xfrm>
-            <a:off x="457200" y="384048"/>
-            <a:ext cx="8229600" cy="594360"/>
+            <a:off x="457200" y="329184"/>
+            <a:ext cx="8229600" cy="548640"/>
           </a:xfrm>
           <a:prstGeom prst="rect">
             <a:avLst/>
@@ -19281,14 +19281,14 @@
               <a:buNone/>
             </a:pPr>
             <a:r>
-              <a:rPr lang="en-US" sz="2000" b="1" dirty="0">
+              <a:rPr lang="en-US" sz="1900" b="1" dirty="0">
                 <a:solidFill>
                   <a:srgbClr val="202124"/>
                 </a:solidFill>
               </a:rPr>
               <a:t>Benchmark Validation Achieves 100% Anchor Discovery &amp; 100% Target Reachability</a:t>
             </a:r>
-            <a:endParaRPr lang="en-US" sz="2000" dirty="0"/>
+            <a:endParaRPr lang="en-US" sz="1900" dirty="0"/>
           </a:p>
         </p:txBody>
       </p:sp>
@@ -19300,8 +19300,8 @@
         </p:nvSpPr>
         <p:spPr>
           <a:xfrm>
-            <a:off x="457200" y="1143000"/>
-            <a:ext cx="8229600" cy="320040"/>
+            <a:off x="457200" y="1645920"/>
+            <a:ext cx="8229600" cy="274320"/>
           </a:xfrm>
           <a:prstGeom prst="rect">
             <a:avLst/>
@@ -19317,14 +19317,14 @@
               <a:buNone/>
             </a:pPr>
             <a:r>
-              <a:rPr lang="en-US" sz="1500" b="1" dirty="0">
+              <a:rPr lang="en-US" sz="1400" b="1" dirty="0">
                 <a:solidFill>
                   <a:srgbClr val="1A73E8"/>
                 </a:solidFill>
               </a:rPr>
               <a:t>Synthetic Benchmark Evaluation Results (N=120 Benchmark Items) &amp; Projected Lift Matrix</a:t>
             </a:r>
-            <a:endParaRPr lang="en-US" sz="1500" dirty="0"/>
+            <a:endParaRPr lang="en-US" sz="1400" dirty="0"/>
           </a:p>
         </p:txBody>
       </p:sp>
@@ -19343,7 +19343,7 @@
           </p:nvPr>
         </p:nvGraphicFramePr>
         <p:xfrm>
-          <a:off x="457200" y="1508760"/>
+          <a:off x="457200" y="1938528"/>
           <a:ext cx="8229600" cy="914400"/>
         </p:xfrm>
         <a:graphic>
@@ -21578,8 +21578,8 @@
         </p:nvSpPr>
         <p:spPr>
           <a:xfrm>
-            <a:off x="457200" y="4937760"/>
-            <a:ext cx="8229600" cy="228600"/>
+            <a:off x="457200" y="4919472"/>
+            <a:ext cx="8229600" cy="201168"/>
           </a:xfrm>
           <a:prstGeom prst="rect">
             <a:avLst/>

</xml_diff>